<commit_message>
Add free-licensed Wikimedia photos (cover, warm-up) with credits to Unit 1 book and web page
Co-Authored-By: Claude Sonnet 5.5 <noreply@anthropic.com>
Claude-Session: https://claude.ai/code/session_01Dfx5njrAxoRTBzPLGm16D8
</commit_message>
<xml_diff>
--- a/curso-ingles/book1/Book1_Unit01_A4.pptx
+++ b/curso-ingles/book1/Book1_Unit01_A4.pptx
@@ -16,9 +16,10 @@
     <p:sldId id="264" r:id="rId10"/>
     <p:sldId id="265" r:id="rId11"/>
     <p:sldId id="266" r:id="rId12"/>
+    <p:sldId id="267" r:id="rId13"/>
   </p:sldIdLst>
   <p:notesMasterIdLst>
-    <p:notesMasterId r:id="rId13"/>
+    <p:notesMasterId r:id="rId14"/>
   </p:notesMasterIdLst>
   <p:sldSz cx="7562088" cy="10689336"/>
   <p:notesSz cx="10689336" cy="7562088"/>
@@ -712,6 +713,94 @@
             <a:fld id="{F7021451-1387-4CA6-816F-3879F97B5CBC}" type="slidenum">
               <a:rPr lang="en-US"/>
               <a:t>11</a:t>
+            </a:fld>
+            <a:endParaRPr lang="en-US"/>
+          </a:p>
+        </p:txBody>
+      </p:sp>
+    </p:spTree>
+    <p:extLst>
+      <p:ext uri="{BB962C8B-B14F-4D97-AF65-F5344CB8AC3E}">
+        <p14:creationId xmlns:p14="http://schemas.microsoft.com/office/powerpoint/2010/main" val="1024086991"/>
+      </p:ext>
+    </p:extLst>
+  </p:cSld>
+  <p:clrMapOvr>
+    <a:masterClrMapping/>
+  </p:clrMapOvr>
+</p:notes>
+</file>
+
+<file path=ppt/notesSlides/notesSlide12.xml><?xml version="1.0" encoding="utf-8"?>
+<p:notes xmlns:a="http://schemas.openxmlformats.org/drawingml/2006/main" xmlns:r="http://schemas.openxmlformats.org/officeDocument/2006/relationships" xmlns:p="http://schemas.openxmlformats.org/presentationml/2006/main">
+  <p:cSld>
+    <p:spTree>
+      <p:nvGrpSpPr>
+        <p:cNvPr id="1" name=""/>
+        <p:cNvGrpSpPr/>
+        <p:nvPr/>
+      </p:nvGrpSpPr>
+      <p:grpSpPr>
+        <a:xfrm>
+          <a:off x="0" y="0"/>
+          <a:ext cx="0" cy="0"/>
+          <a:chOff x="0" y="0"/>
+          <a:chExt cx="0" cy="0"/>
+        </a:xfrm>
+      </p:grpSpPr>
+      <p:sp>
+        <p:nvSpPr>
+          <p:cNvPr id="2" name="Slide Image Placeholder 1"/>
+          <p:cNvSpPr>
+            <a:spLocks noGrp="1" noRot="1" noChangeAspect="1"/>
+          </p:cNvSpPr>
+          <p:nvPr>
+            <p:ph type="sldImg"/>
+          </p:nvPr>
+        </p:nvSpPr>
+        <p:spPr/>
+      </p:sp>
+      <p:sp>
+        <p:nvSpPr>
+          <p:cNvPr id="3" name="Notes Placeholder 2"/>
+          <p:cNvSpPr>
+            <a:spLocks noGrp="1"/>
+          </p:cNvSpPr>
+          <p:nvPr>
+            <p:ph type="body" idx="1"/>
+          </p:nvPr>
+        </p:nvSpPr>
+        <p:spPr/>
+        <p:txBody>
+          <a:bodyPr/>
+          <a:lstStyle/>
+          <a:p>
+            <a:r>
+              <a:rPr lang="en-US" dirty="0"/>
+              <a:t/>
+            </a:r>
+            <a:endParaRPr lang="en-US" dirty="0"/>
+          </a:p>
+        </p:txBody>
+      </p:sp>
+      <p:sp>
+        <p:nvSpPr>
+          <p:cNvPr id="4" name="Slide Number Placeholder 3"/>
+          <p:cNvSpPr>
+            <a:spLocks noGrp="1"/>
+          </p:cNvSpPr>
+          <p:nvPr>
+            <p:ph type="sldNum" sz="quarter" idx="10"/>
+          </p:nvPr>
+        </p:nvSpPr>
+        <p:spPr/>
+        <p:txBody>
+          <a:bodyPr/>
+          <a:lstStyle/>
+          <a:p>
+            <a:fld id="{F7021451-1387-4CA6-816F-3879F97B5CBC}" type="slidenum">
+              <a:rPr lang="en-US"/>
+              <a:t>12</a:t>
             </a:fld>
             <a:endParaRPr lang="en-US"/>
           </a:p>
@@ -2109,24 +2198,86 @@
           </a:p>
         </p:txBody>
       </p:sp>
-      <p:sp>
-        <p:nvSpPr>
-          <p:cNvPr id="7" name="Photo area"/>
-          <p:cNvSpPr/>
-          <p:nvPr/>
-        </p:nvSpPr>
+      <p:pic>
+        <p:nvPicPr>
+          <p:cNvPr id="7" name="Image 0" descr="cover">    </p:cNvPr>
+          <p:cNvPicPr>
+            <a:picLocks noChangeAspect="1"/>
+          </p:cNvPicPr>
+          <p:nvPr/>
+        </p:nvPicPr>
+        <p:blipFill>
+          <a:blip r:embed="rId1"/>
+          <a:srcRect l="0" r="0" t="0" b="0"/>
+          <a:stretch/>
+        </p:blipFill>
         <p:spPr>
           <a:xfrm>
             <a:off x="548640" y="2606040"/>
             <a:ext cx="6464808" cy="3291840"/>
           </a:xfrm>
+          <a:prstGeom prst="rect">
+            <a:avLst/>
+          </a:prstGeom>
+        </p:spPr>
+      </p:pic>
+      <p:sp>
+        <p:nvSpPr>
+          <p:cNvPr id="8" name="Text 5"/>
+          <p:cNvSpPr txBox="1"/>
+          <p:nvPr/>
+        </p:nvSpPr>
+        <p:spPr>
+          <a:xfrm>
+            <a:off x="548640" y="6172200"/>
+            <a:ext cx="6464808" cy="365760"/>
+          </a:xfrm>
+          <a:prstGeom prst="rect">
+            <a:avLst/>
+          </a:prstGeom>
+          <a:noFill/>
+          <a:ln/>
+        </p:spPr>
+        <p:txBody>
+          <a:bodyPr wrap="square" lIns="0" tIns="0" rIns="0" bIns="0" rtlCol="0" anchor="t"/>
+          <a:lstStyle/>
+          <a:p>
+            <a:pPr indent="0" marL="0">
+              <a:buNone/>
+            </a:pPr>
+            <a:r>
+              <a:rPr lang="en-US" sz="2000" b="1" dirty="0">
+                <a:solidFill>
+                  <a:srgbClr val="001737"/>
+                </a:solidFill>
+                <a:latin typeface="Calibri" pitchFamily="34" charset="0"/>
+                <a:ea typeface="Calibri" pitchFamily="34" charset="-122"/>
+                <a:cs typeface="Calibri" pitchFamily="34" charset="-120"/>
+              </a:rPr>
+              <a:t>In this unit, I can…</a:t>
+            </a:r>
+            <a:endParaRPr lang="en-US" sz="2000" dirty="0"/>
+          </a:p>
+        </p:txBody>
+      </p:sp>
+      <p:sp>
+        <p:nvSpPr>
+          <p:cNvPr id="9" name="Box"/>
+          <p:cNvSpPr/>
+          <p:nvPr/>
+        </p:nvSpPr>
+        <p:spPr>
+          <a:xfrm>
+            <a:off x="548640" y="6629400"/>
+            <a:ext cx="3172968" cy="1078992"/>
+          </a:xfrm>
           <a:prstGeom prst="roundRect">
             <a:avLst>
-              <a:gd name="adj" fmla="val 2778"/>
+              <a:gd name="adj" fmla="val 8475"/>
             </a:avLst>
           </a:prstGeom>
           <a:solidFill>
-            <a:srgbClr val="F3F6FB"/>
+            <a:srgbClr val="FFF4BF"/>
           </a:solidFill>
           <a:ln w="12700">
             <a:solidFill>
@@ -2136,45 +2287,19 @@
           </a:ln>
         </p:spPr>
       </p:sp>
-      <p:pic>
-        <p:nvPicPr>
-          <p:cNvPr id="8" name="Image 0" descr="Tom">    </p:cNvPr>
-          <p:cNvPicPr>
-            <a:picLocks noChangeAspect="1"/>
-          </p:cNvPicPr>
-          <p:nvPr/>
-        </p:nvPicPr>
-        <p:blipFill>
-          <a:blip r:embed="rId1"/>
-          <a:stretch>
-            <a:fillRect/>
-          </a:stretch>
-        </p:blipFill>
-        <p:spPr>
-          <a:xfrm>
-            <a:off x="1097280" y="2926080"/>
-            <a:ext cx="1554480" cy="1554480"/>
-          </a:xfrm>
-          <a:prstGeom prst="rect">
-            <a:avLst/>
-          </a:prstGeom>
-        </p:spPr>
-      </p:pic>
-      <p:sp>
-        <p:nvSpPr>
-          <p:cNvPr id="9" name="Pill"/>
+      <p:sp>
+        <p:nvSpPr>
+          <p:cNvPr id="10" name="Badge"/>
           <p:cNvSpPr/>
           <p:nvPr/>
         </p:nvSpPr>
         <p:spPr>
           <a:xfrm>
-            <a:off x="2743200" y="3063240"/>
-            <a:ext cx="1371600" cy="502920"/>
-          </a:xfrm>
-          <a:prstGeom prst="roundRect">
-            <a:avLst>
-              <a:gd name="adj" fmla="val 50000"/>
-            </a:avLst>
+            <a:off x="685800" y="6903720"/>
+            <a:ext cx="530352" cy="530352"/>
+          </a:xfrm>
+          <a:prstGeom prst="ellipse">
+            <a:avLst/>
           </a:prstGeom>
           <a:solidFill>
             <a:srgbClr val="FFFFFF"/>
@@ -2187,48 +2312,9 @@
           </a:ln>
         </p:spPr>
       </p:sp>
-      <p:sp>
-        <p:nvSpPr>
-          <p:cNvPr id="10" name="Text 7"/>
-          <p:cNvSpPr txBox="1"/>
-          <p:nvPr/>
-        </p:nvSpPr>
-        <p:spPr>
-          <a:xfrm>
-            <a:off x="2743200" y="3063240"/>
-            <a:ext cx="1371600" cy="502920"/>
-          </a:xfrm>
-          <a:prstGeom prst="rect">
-            <a:avLst/>
-          </a:prstGeom>
-          <a:noFill/>
-          <a:ln/>
-        </p:spPr>
-        <p:txBody>
-          <a:bodyPr wrap="square" lIns="0" tIns="0" rIns="0" bIns="0" rtlCol="0" anchor="ctr"/>
-          <a:lstStyle/>
-          <a:p>
-            <a:pPr algn="ctr" indent="0" marL="0">
-              <a:buNone/>
-            </a:pPr>
-            <a:r>
-              <a:rPr lang="en-US" sz="1800" b="1" dirty="0">
-                <a:solidFill>
-                  <a:srgbClr val="001737"/>
-                </a:solidFill>
-                <a:latin typeface="Calibri" pitchFamily="34" charset="0"/>
-                <a:ea typeface="Calibri" pitchFamily="34" charset="-122"/>
-                <a:cs typeface="Calibri" pitchFamily="34" charset="-120"/>
-              </a:rPr>
-              <a:t>Hello!</a:t>
-            </a:r>
-            <a:endParaRPr lang="en-US" sz="1800" dirty="0"/>
-          </a:p>
-        </p:txBody>
-      </p:sp>
       <p:pic>
         <p:nvPicPr>
-          <p:cNvPr id="11" name="Image 1" descr="Ana">    </p:cNvPr>
+          <p:cNvPr id="11" name="Image 1" descr="Greet people">    </p:cNvPr>
           <p:cNvPicPr>
             <a:picLocks noChangeAspect="1"/>
           </p:cNvPicPr>
@@ -2242,8 +2328,8 @@
         </p:blipFill>
         <p:spPr>
           <a:xfrm>
-            <a:off x="5029200" y="3566160"/>
-            <a:ext cx="1554480" cy="1554480"/>
+            <a:off x="813816" y="7031736"/>
+            <a:ext cx="274320" cy="274320"/>
           </a:xfrm>
           <a:prstGeom prst="rect">
             <a:avLst/>
@@ -2252,26 +2338,174 @@
       </p:pic>
       <p:sp>
         <p:nvSpPr>
-          <p:cNvPr id="12" name="Pill"/>
+          <p:cNvPr id="12" name="Text 8"/>
+          <p:cNvSpPr txBox="1"/>
+          <p:nvPr/>
+        </p:nvSpPr>
+        <p:spPr>
+          <a:xfrm>
+            <a:off x="1371600" y="6739128"/>
+            <a:ext cx="2286000" cy="320040"/>
+          </a:xfrm>
+          <a:prstGeom prst="rect">
+            <a:avLst/>
+          </a:prstGeom>
+          <a:noFill/>
+          <a:ln/>
+        </p:spPr>
+        <p:txBody>
+          <a:bodyPr wrap="square" lIns="0" tIns="0" rIns="0" bIns="0" rtlCol="0" anchor="ctr"/>
+          <a:lstStyle/>
+          <a:p>
+            <a:pPr indent="0" marL="0">
+              <a:buNone/>
+            </a:pPr>
+            <a:r>
+              <a:rPr lang="en-US" sz="1800" b="1" dirty="0">
+                <a:solidFill>
+                  <a:srgbClr val="001737"/>
+                </a:solidFill>
+                <a:latin typeface="Arial Narrow" pitchFamily="34" charset="0"/>
+                <a:ea typeface="Arial Narrow" pitchFamily="34" charset="-122"/>
+                <a:cs typeface="Arial Narrow" pitchFamily="34" charset="-120"/>
+              </a:rPr>
+              <a:t>Greet people</a:t>
+            </a:r>
+            <a:endParaRPr lang="en-US" sz="1800" dirty="0"/>
+          </a:p>
+        </p:txBody>
+      </p:sp>
+      <p:sp>
+        <p:nvSpPr>
+          <p:cNvPr id="13" name="Text 9"/>
+          <p:cNvSpPr txBox="1"/>
+          <p:nvPr/>
+        </p:nvSpPr>
+        <p:spPr>
+          <a:xfrm>
+            <a:off x="1371600" y="7086600"/>
+            <a:ext cx="2240280" cy="548640"/>
+          </a:xfrm>
+          <a:prstGeom prst="rect">
+            <a:avLst/>
+          </a:prstGeom>
+          <a:noFill/>
+          <a:ln/>
+        </p:spPr>
+        <p:txBody>
+          <a:bodyPr wrap="square" lIns="0" tIns="0" rIns="0" bIns="0" rtlCol="0" anchor="t"/>
+          <a:lstStyle/>
+          <a:p>
+            <a:pPr indent="0" marL="0">
+              <a:buNone/>
+            </a:pPr>
+            <a:r>
+              <a:rPr lang="en-US" sz="1100" dirty="0">
+                <a:solidFill>
+                  <a:srgbClr val="5B6B82"/>
+                </a:solidFill>
+                <a:latin typeface="Calibri" pitchFamily="34" charset="0"/>
+                <a:ea typeface="Calibri" pitchFamily="34" charset="-122"/>
+                <a:cs typeface="Calibri" pitchFamily="34" charset="-120"/>
+              </a:rPr>
+              <a:t>dizer </a:t>
+            </a:r>
+            <a:pPr indent="0" marL="0">
+              <a:buNone/>
+            </a:pPr>
+            <a:r>
+              <a:rPr lang="en-US" sz="1100" b="1" dirty="0">
+                <a:solidFill>
+                  <a:srgbClr val="B45309"/>
+                </a:solidFill>
+                <a:latin typeface="Calibri" pitchFamily="34" charset="0"/>
+                <a:ea typeface="Calibri" pitchFamily="34" charset="-122"/>
+                <a:cs typeface="Calibri" pitchFamily="34" charset="-120"/>
+              </a:rPr>
+              <a:t>Hello</a:t>
+            </a:r>
+            <a:pPr indent="0" marL="0">
+              <a:buNone/>
+            </a:pPr>
+            <a:r>
+              <a:rPr lang="en-US" sz="1100" dirty="0">
+                <a:solidFill>
+                  <a:srgbClr val="5B6B82"/>
+                </a:solidFill>
+                <a:latin typeface="Calibri" pitchFamily="34" charset="0"/>
+                <a:ea typeface="Calibri" pitchFamily="34" charset="-122"/>
+                <a:cs typeface="Calibri" pitchFamily="34" charset="-120"/>
+              </a:rPr>
+              <a:t>, </a:t>
+            </a:r>
+            <a:pPr indent="0" marL="0">
+              <a:buNone/>
+            </a:pPr>
+            <a:r>
+              <a:rPr lang="en-US" sz="1100" b="1" dirty="0">
+                <a:solidFill>
+                  <a:srgbClr val="B45309"/>
+                </a:solidFill>
+                <a:latin typeface="Calibri" pitchFamily="34" charset="0"/>
+                <a:ea typeface="Calibri" pitchFamily="34" charset="-122"/>
+                <a:cs typeface="Calibri" pitchFamily="34" charset="-120"/>
+              </a:rPr>
+              <a:t>Good morning</a:t>
+            </a:r>
+            <a:pPr indent="0" marL="0">
+              <a:buNone/>
+            </a:pPr>
+            <a:r>
+              <a:rPr lang="en-US" sz="1100" dirty="0">
+                <a:solidFill>
+                  <a:srgbClr val="5B6B82"/>
+                </a:solidFill>
+                <a:latin typeface="Calibri" pitchFamily="34" charset="0"/>
+                <a:ea typeface="Calibri" pitchFamily="34" charset="-122"/>
+                <a:cs typeface="Calibri" pitchFamily="34" charset="-120"/>
+              </a:rPr>
+              <a:t> e </a:t>
+            </a:r>
+            <a:pPr indent="0" marL="0">
+              <a:buNone/>
+            </a:pPr>
+            <a:r>
+              <a:rPr lang="en-US" sz="1100" b="1" dirty="0">
+                <a:solidFill>
+                  <a:srgbClr val="B45309"/>
+                </a:solidFill>
+                <a:latin typeface="Calibri" pitchFamily="34" charset="0"/>
+                <a:ea typeface="Calibri" pitchFamily="34" charset="-122"/>
+                <a:cs typeface="Calibri" pitchFamily="34" charset="-120"/>
+              </a:rPr>
+              <a:t>Goodbye</a:t>
+            </a:r>
+            <a:endParaRPr lang="en-US" sz="1100" dirty="0"/>
+          </a:p>
+        </p:txBody>
+      </p:sp>
+      <p:sp>
+        <p:nvSpPr>
+          <p:cNvPr id="14" name="Box"/>
           <p:cNvSpPr/>
           <p:nvPr/>
         </p:nvSpPr>
         <p:spPr>
           <a:xfrm>
-            <a:off x="3291840" y="3977640"/>
-            <a:ext cx="1554480" cy="502920"/>
+            <a:off x="3840480" y="6629400"/>
+            <a:ext cx="3172968" cy="1078992"/>
           </a:xfrm>
           <a:prstGeom prst="roundRect">
             <a:avLst>
-              <a:gd name="adj" fmla="val 50000"/>
+              <a:gd name="adj" fmla="val 8475"/>
             </a:avLst>
           </a:prstGeom>
           <a:solidFill>
-            <a:srgbClr val="FFCD04"/>
+            <a:srgbClr val="E6F3FF"/>
           </a:solidFill>
           <a:ln w="12700">
             <a:solidFill>
-              <a:srgbClr val="FFCD04"/>
+              <a:srgbClr val="D5DCE8"/>
             </a:solidFill>
             <a:prstDash val="solid"/>
           </a:ln>
@@ -2279,82 +2513,17 @@
       </p:sp>
       <p:sp>
         <p:nvSpPr>
-          <p:cNvPr id="13" name="Text 9"/>
-          <p:cNvSpPr txBox="1"/>
-          <p:nvPr/>
-        </p:nvSpPr>
-        <p:spPr>
-          <a:xfrm>
-            <a:off x="3291840" y="3977640"/>
-            <a:ext cx="1554480" cy="502920"/>
-          </a:xfrm>
-          <a:prstGeom prst="rect">
-            <a:avLst/>
-          </a:prstGeom>
-          <a:noFill/>
-          <a:ln/>
-        </p:spPr>
-        <p:txBody>
-          <a:bodyPr wrap="square" lIns="0" tIns="0" rIns="0" bIns="0" rtlCol="0" anchor="ctr"/>
-          <a:lstStyle/>
-          <a:p>
-            <a:pPr algn="ctr" indent="0" marL="0">
-              <a:buNone/>
-            </a:pPr>
-            <a:r>
-              <a:rPr lang="en-US" sz="1800" b="1" dirty="0">
-                <a:solidFill>
-                  <a:srgbClr val="001737"/>
-                </a:solidFill>
-                <a:latin typeface="Calibri" pitchFamily="34" charset="0"/>
-                <a:ea typeface="Calibri" pitchFamily="34" charset="-122"/>
-                <a:cs typeface="Calibri" pitchFamily="34" charset="-120"/>
-              </a:rPr>
-              <a:t>Hi, Tom!</a:t>
-            </a:r>
-            <a:endParaRPr lang="en-US" sz="1800" dirty="0"/>
-          </a:p>
-        </p:txBody>
-      </p:sp>
-      <p:pic>
-        <p:nvPicPr>
-          <p:cNvPr id="14" name="Image 2" descr="Yuki">    </p:cNvPr>
-          <p:cNvPicPr>
-            <a:picLocks noChangeAspect="1"/>
-          </p:cNvPicPr>
-          <p:nvPr/>
-        </p:nvPicPr>
-        <p:blipFill>
-          <a:blip r:embed="rId3"/>
-          <a:stretch>
-            <a:fillRect/>
-          </a:stretch>
-        </p:blipFill>
-        <p:spPr>
-          <a:xfrm>
-            <a:off x="1737360" y="4389120"/>
-            <a:ext cx="1280160" cy="1280160"/>
-          </a:xfrm>
-          <a:prstGeom prst="rect">
-            <a:avLst/>
-          </a:prstGeom>
-        </p:spPr>
-      </p:pic>
-      <p:sp>
-        <p:nvSpPr>
-          <p:cNvPr id="15" name="Pill"/>
+          <p:cNvPr id="15" name="Badge"/>
           <p:cNvSpPr/>
           <p:nvPr/>
         </p:nvSpPr>
         <p:spPr>
           <a:xfrm>
-            <a:off x="3200400" y="4754880"/>
-            <a:ext cx="1554480" cy="502920"/>
-          </a:xfrm>
-          <a:prstGeom prst="roundRect">
-            <a:avLst>
-              <a:gd name="adj" fmla="val 50000"/>
-            </a:avLst>
+            <a:off x="3977640" y="6903720"/>
+            <a:ext cx="530352" cy="530352"/>
+          </a:xfrm>
+          <a:prstGeom prst="ellipse">
+            <a:avLst/>
           </a:prstGeom>
           <a:solidFill>
             <a:srgbClr val="FFFFFF"/>
@@ -2367,28 +2536,52 @@
           </a:ln>
         </p:spPr>
       </p:sp>
-      <p:sp>
-        <p:nvSpPr>
-          <p:cNvPr id="16" name="Text 11"/>
-          <p:cNvSpPr txBox="1"/>
-          <p:nvPr/>
-        </p:nvSpPr>
-        <p:spPr>
-          <a:xfrm>
-            <a:off x="3200400" y="4754880"/>
-            <a:ext cx="1554480" cy="502920"/>
-          </a:xfrm>
-          <a:prstGeom prst="rect">
-            <a:avLst/>
-          </a:prstGeom>
-          <a:noFill/>
-          <a:ln/>
-        </p:spPr>
-        <p:txBody>
-          <a:bodyPr wrap="square" lIns="0" tIns="0" rIns="0" bIns="0" rtlCol="0" anchor="ctr"/>
-          <a:lstStyle/>
-          <a:p>
-            <a:pPr algn="ctr" indent="0" marL="0">
+      <p:pic>
+        <p:nvPicPr>
+          <p:cNvPr id="16" name="Image 2" descr="Introduce myself">    </p:cNvPr>
+          <p:cNvPicPr>
+            <a:picLocks noChangeAspect="1"/>
+          </p:cNvPicPr>
+          <p:nvPr/>
+        </p:nvPicPr>
+        <p:blipFill>
+          <a:blip r:embed="rId3"/>
+          <a:stretch>
+            <a:fillRect/>
+          </a:stretch>
+        </p:blipFill>
+        <p:spPr>
+          <a:xfrm>
+            <a:off x="4105656" y="7031736"/>
+            <a:ext cx="274320" cy="274320"/>
+          </a:xfrm>
+          <a:prstGeom prst="rect">
+            <a:avLst/>
+          </a:prstGeom>
+        </p:spPr>
+      </p:pic>
+      <p:sp>
+        <p:nvSpPr>
+          <p:cNvPr id="17" name="Text 12"/>
+          <p:cNvSpPr txBox="1"/>
+          <p:nvPr/>
+        </p:nvSpPr>
+        <p:spPr>
+          <a:xfrm>
+            <a:off x="4663440" y="6739128"/>
+            <a:ext cx="2286000" cy="320040"/>
+          </a:xfrm>
+          <a:prstGeom prst="rect">
+            <a:avLst/>
+          </a:prstGeom>
+          <a:noFill/>
+          <a:ln/>
+        </p:spPr>
+        <p:txBody>
+          <a:bodyPr wrap="square" lIns="0" tIns="0" rIns="0" bIns="0" rtlCol="0" anchor="ctr"/>
+          <a:lstStyle/>
+          <a:p>
+            <a:pPr indent="0" marL="0">
               <a:buNone/>
             </a:pPr>
             <a:r>
@@ -2396,11 +2589,11 @@
                 <a:solidFill>
                   <a:srgbClr val="001737"/>
                 </a:solidFill>
-                <a:latin typeface="Calibri" pitchFamily="34" charset="0"/>
-                <a:ea typeface="Calibri" pitchFamily="34" charset="-122"/>
-                <a:cs typeface="Calibri" pitchFamily="34" charset="-120"/>
-              </a:rPr>
-              <a:t>I'm Yuki.</a:t>
+                <a:latin typeface="Arial Narrow" pitchFamily="34" charset="0"/>
+                <a:ea typeface="Arial Narrow" pitchFamily="34" charset="-122"/>
+                <a:cs typeface="Arial Narrow" pitchFamily="34" charset="-120"/>
+              </a:rPr>
+              <a:t>Introduce myself</a:t>
             </a:r>
             <a:endParaRPr lang="en-US" sz="1800" dirty="0"/>
           </a:p>
@@ -2408,14 +2601,14 @@
       </p:sp>
       <p:sp>
         <p:nvSpPr>
-          <p:cNvPr id="17" name="Text 12"/>
-          <p:cNvSpPr txBox="1"/>
-          <p:nvPr/>
-        </p:nvSpPr>
-        <p:spPr>
-          <a:xfrm>
-            <a:off x="548640" y="6172200"/>
-            <a:ext cx="6464808" cy="365760"/>
+          <p:cNvPr id="18" name="Text 13"/>
+          <p:cNvSpPr txBox="1"/>
+          <p:nvPr/>
+        </p:nvSpPr>
+        <p:spPr>
+          <a:xfrm>
+            <a:off x="4663440" y="7086600"/>
+            <a:ext cx="2240280" cy="548640"/>
           </a:xfrm>
           <a:prstGeom prst="rect">
             <a:avLst/>
@@ -2431,29 +2624,29 @@
               <a:buNone/>
             </a:pPr>
             <a:r>
-              <a:rPr lang="en-US" sz="2000" b="1" dirty="0">
-                <a:solidFill>
-                  <a:srgbClr val="001737"/>
-                </a:solidFill>
-                <a:latin typeface="Calibri" pitchFamily="34" charset="0"/>
-                <a:ea typeface="Calibri" pitchFamily="34" charset="-122"/>
-                <a:cs typeface="Calibri" pitchFamily="34" charset="-120"/>
-              </a:rPr>
-              <a:t>In this unit, I can…</a:t>
-            </a:r>
-            <a:endParaRPr lang="en-US" sz="2000" dirty="0"/>
-          </a:p>
-        </p:txBody>
-      </p:sp>
-      <p:sp>
-        <p:nvSpPr>
-          <p:cNvPr id="18" name="Box"/>
+              <a:rPr lang="en-US" sz="1100" dirty="0">
+                <a:solidFill>
+                  <a:srgbClr val="5B6B82"/>
+                </a:solidFill>
+                <a:latin typeface="Calibri" pitchFamily="34" charset="0"/>
+                <a:ea typeface="Calibri" pitchFamily="34" charset="-122"/>
+                <a:cs typeface="Calibri" pitchFamily="34" charset="-120"/>
+              </a:rPr>
+              <a:t>dizer meu nome e perguntar o nome de alguém</a:t>
+            </a:r>
+            <a:endParaRPr lang="en-US" sz="1100" dirty="0"/>
+          </a:p>
+        </p:txBody>
+      </p:sp>
+      <p:sp>
+        <p:nvSpPr>
+          <p:cNvPr id="19" name="Box"/>
           <p:cNvSpPr/>
           <p:nvPr/>
         </p:nvSpPr>
         <p:spPr>
           <a:xfrm>
-            <a:off x="548640" y="6629400"/>
+            <a:off x="548640" y="7818120"/>
             <a:ext cx="3172968" cy="1078992"/>
           </a:xfrm>
           <a:prstGeom prst="roundRect">
@@ -2462,7 +2655,7 @@
             </a:avLst>
           </a:prstGeom>
           <a:solidFill>
-            <a:srgbClr val="FFF4BF"/>
+            <a:srgbClr val="E2F7EE"/>
           </a:solidFill>
           <a:ln w="12700">
             <a:solidFill>
@@ -2474,13 +2667,13 @@
       </p:sp>
       <p:sp>
         <p:nvSpPr>
-          <p:cNvPr id="19" name="Badge"/>
+          <p:cNvPr id="20" name="Badge"/>
           <p:cNvSpPr/>
           <p:nvPr/>
         </p:nvSpPr>
         <p:spPr>
           <a:xfrm>
-            <a:off x="685800" y="6903720"/>
+            <a:off x="685800" y="8092440"/>
             <a:ext cx="530352" cy="530352"/>
           </a:xfrm>
           <a:prstGeom prst="ellipse">
@@ -2499,7 +2692,7 @@
       </p:sp>
       <p:pic>
         <p:nvPicPr>
-          <p:cNvPr id="20" name="Image 3" descr="Greet people">    </p:cNvPr>
+          <p:cNvPr id="21" name="Image 3" descr="Say where I'm from">    </p:cNvPr>
           <p:cNvPicPr>
             <a:picLocks noChangeAspect="1"/>
           </p:cNvPicPr>
@@ -2513,7 +2706,7 @@
         </p:blipFill>
         <p:spPr>
           <a:xfrm>
-            <a:off x="813816" y="7031736"/>
+            <a:off x="813816" y="8220456"/>
             <a:ext cx="274320" cy="274320"/>
           </a:xfrm>
           <a:prstGeom prst="rect">
@@ -2523,13 +2716,13 @@
       </p:pic>
       <p:sp>
         <p:nvSpPr>
-          <p:cNvPr id="21" name="Text 15"/>
-          <p:cNvSpPr txBox="1"/>
-          <p:nvPr/>
-        </p:nvSpPr>
-        <p:spPr>
-          <a:xfrm>
-            <a:off x="1371600" y="6739128"/>
+          <p:cNvPr id="22" name="Text 16"/>
+          <p:cNvSpPr txBox="1"/>
+          <p:nvPr/>
+        </p:nvSpPr>
+        <p:spPr>
+          <a:xfrm>
+            <a:off x="1371600" y="7927848"/>
             <a:ext cx="2286000" cy="320040"/>
           </a:xfrm>
           <a:prstGeom prst="rect">
@@ -2554,7 +2747,7 @@
                 <a:ea typeface="Arial Narrow" pitchFamily="34" charset="-122"/>
                 <a:cs typeface="Arial Narrow" pitchFamily="34" charset="-120"/>
               </a:rPr>
-              <a:t>Greet people</a:t>
+              <a:t>Say where I'm from</a:t>
             </a:r>
             <a:endParaRPr lang="en-US" sz="1800" dirty="0"/>
           </a:p>
@@ -2562,13 +2755,13 @@
       </p:sp>
       <p:sp>
         <p:nvSpPr>
-          <p:cNvPr id="22" name="Text 16"/>
-          <p:cNvSpPr txBox="1"/>
-          <p:nvPr/>
-        </p:nvSpPr>
-        <p:spPr>
-          <a:xfrm>
-            <a:off x="1371600" y="7086600"/>
+          <p:cNvPr id="23" name="Text 17"/>
+          <p:cNvSpPr txBox="1"/>
+          <p:nvPr/>
+        </p:nvSpPr>
+        <p:spPr>
+          <a:xfrm>
+            <a:off x="1371600" y="8275320"/>
             <a:ext cx="2240280" cy="548640"/>
           </a:xfrm>
           <a:prstGeom prst="rect">
@@ -2593,77 +2786,7 @@
                 <a:ea typeface="Calibri" pitchFamily="34" charset="-122"/>
                 <a:cs typeface="Calibri" pitchFamily="34" charset="-120"/>
               </a:rPr>
-              <a:t>dizer </a:t>
-            </a:r>
-            <a:pPr indent="0" marL="0">
-              <a:buNone/>
-            </a:pPr>
-            <a:r>
-              <a:rPr lang="en-US" sz="1100" b="1" dirty="0">
-                <a:solidFill>
-                  <a:srgbClr val="B45309"/>
-                </a:solidFill>
-                <a:latin typeface="Calibri" pitchFamily="34" charset="0"/>
-                <a:ea typeface="Calibri" pitchFamily="34" charset="-122"/>
-                <a:cs typeface="Calibri" pitchFamily="34" charset="-120"/>
-              </a:rPr>
-              <a:t>Hello</a:t>
-            </a:r>
-            <a:pPr indent="0" marL="0">
-              <a:buNone/>
-            </a:pPr>
-            <a:r>
-              <a:rPr lang="en-US" sz="1100" dirty="0">
-                <a:solidFill>
-                  <a:srgbClr val="5B6B82"/>
-                </a:solidFill>
-                <a:latin typeface="Calibri" pitchFamily="34" charset="0"/>
-                <a:ea typeface="Calibri" pitchFamily="34" charset="-122"/>
-                <a:cs typeface="Calibri" pitchFamily="34" charset="-120"/>
-              </a:rPr>
-              <a:t>, </a:t>
-            </a:r>
-            <a:pPr indent="0" marL="0">
-              <a:buNone/>
-            </a:pPr>
-            <a:r>
-              <a:rPr lang="en-US" sz="1100" b="1" dirty="0">
-                <a:solidFill>
-                  <a:srgbClr val="B45309"/>
-                </a:solidFill>
-                <a:latin typeface="Calibri" pitchFamily="34" charset="0"/>
-                <a:ea typeface="Calibri" pitchFamily="34" charset="-122"/>
-                <a:cs typeface="Calibri" pitchFamily="34" charset="-120"/>
-              </a:rPr>
-              <a:t>Good morning</a:t>
-            </a:r>
-            <a:pPr indent="0" marL="0">
-              <a:buNone/>
-            </a:pPr>
-            <a:r>
-              <a:rPr lang="en-US" sz="1100" dirty="0">
-                <a:solidFill>
-                  <a:srgbClr val="5B6B82"/>
-                </a:solidFill>
-                <a:latin typeface="Calibri" pitchFamily="34" charset="0"/>
-                <a:ea typeface="Calibri" pitchFamily="34" charset="-122"/>
-                <a:cs typeface="Calibri" pitchFamily="34" charset="-120"/>
-              </a:rPr>
-              <a:t> e </a:t>
-            </a:r>
-            <a:pPr indent="0" marL="0">
-              <a:buNone/>
-            </a:pPr>
-            <a:r>
-              <a:rPr lang="en-US" sz="1100" b="1" dirty="0">
-                <a:solidFill>
-                  <a:srgbClr val="B45309"/>
-                </a:solidFill>
-                <a:latin typeface="Calibri" pitchFamily="34" charset="0"/>
-                <a:ea typeface="Calibri" pitchFamily="34" charset="-122"/>
-                <a:cs typeface="Calibri" pitchFamily="34" charset="-120"/>
-              </a:rPr>
-              <a:t>Goodbye</a:t>
+              <a:t>dizer meu país, nacionalidade e profissão</a:t>
             </a:r>
             <a:endParaRPr lang="en-US" sz="1100" dirty="0"/>
           </a:p>
@@ -2671,13 +2794,13 @@
       </p:sp>
       <p:sp>
         <p:nvSpPr>
-          <p:cNvPr id="23" name="Box"/>
+          <p:cNvPr id="24" name="Box"/>
           <p:cNvSpPr/>
           <p:nvPr/>
         </p:nvSpPr>
         <p:spPr>
           <a:xfrm>
-            <a:off x="3840480" y="6629400"/>
+            <a:off x="3840480" y="7818120"/>
             <a:ext cx="3172968" cy="1078992"/>
           </a:xfrm>
           <a:prstGeom prst="roundRect">
@@ -2686,7 +2809,7 @@
             </a:avLst>
           </a:prstGeom>
           <a:solidFill>
-            <a:srgbClr val="E6F3FF"/>
+            <a:srgbClr val="EFEAFE"/>
           </a:solidFill>
           <a:ln w="12700">
             <a:solidFill>
@@ -2698,13 +2821,13 @@
       </p:sp>
       <p:sp>
         <p:nvSpPr>
-          <p:cNvPr id="24" name="Badge"/>
+          <p:cNvPr id="25" name="Badge"/>
           <p:cNvSpPr/>
           <p:nvPr/>
         </p:nvSpPr>
         <p:spPr>
           <a:xfrm>
-            <a:off x="3977640" y="6903720"/>
+            <a:off x="3977640" y="8092440"/>
             <a:ext cx="530352" cy="530352"/>
           </a:xfrm>
           <a:prstGeom prst="ellipse">
@@ -2723,7 +2846,7 @@
       </p:sp>
       <p:pic>
         <p:nvPicPr>
-          <p:cNvPr id="25" name="Image 4" descr="Introduce myself">    </p:cNvPr>
+          <p:cNvPr id="26" name="Image 4" descr="Spell words">    </p:cNvPr>
           <p:cNvPicPr>
             <a:picLocks noChangeAspect="1"/>
           </p:cNvPicPr>
@@ -2737,7 +2860,7 @@
         </p:blipFill>
         <p:spPr>
           <a:xfrm>
-            <a:off x="4105656" y="7031736"/>
+            <a:off x="4105656" y="8220456"/>
             <a:ext cx="274320" cy="274320"/>
           </a:xfrm>
           <a:prstGeom prst="rect">
@@ -2747,13 +2870,13 @@
       </p:pic>
       <p:sp>
         <p:nvSpPr>
-          <p:cNvPr id="26" name="Text 19"/>
-          <p:cNvSpPr txBox="1"/>
-          <p:nvPr/>
-        </p:nvSpPr>
-        <p:spPr>
-          <a:xfrm>
-            <a:off x="4663440" y="6739128"/>
+          <p:cNvPr id="27" name="Text 20"/>
+          <p:cNvSpPr txBox="1"/>
+          <p:nvPr/>
+        </p:nvSpPr>
+        <p:spPr>
+          <a:xfrm>
+            <a:off x="4663440" y="7927848"/>
             <a:ext cx="2286000" cy="320040"/>
           </a:xfrm>
           <a:prstGeom prst="rect">
@@ -2778,7 +2901,7 @@
                 <a:ea typeface="Arial Narrow" pitchFamily="34" charset="-122"/>
                 <a:cs typeface="Arial Narrow" pitchFamily="34" charset="-120"/>
               </a:rPr>
-              <a:t>Introduce myself</a:t>
+              <a:t>Spell words</a:t>
             </a:r>
             <a:endParaRPr lang="en-US" sz="1800" dirty="0"/>
           </a:p>
@@ -2786,315 +2909,7 @@
       </p:sp>
       <p:sp>
         <p:nvSpPr>
-          <p:cNvPr id="27" name="Text 20"/>
-          <p:cNvSpPr txBox="1"/>
-          <p:nvPr/>
-        </p:nvSpPr>
-        <p:spPr>
-          <a:xfrm>
-            <a:off x="4663440" y="7086600"/>
-            <a:ext cx="2240280" cy="548640"/>
-          </a:xfrm>
-          <a:prstGeom prst="rect">
-            <a:avLst/>
-          </a:prstGeom>
-          <a:noFill/>
-          <a:ln/>
-        </p:spPr>
-        <p:txBody>
-          <a:bodyPr wrap="square" lIns="0" tIns="0" rIns="0" bIns="0" rtlCol="0" anchor="t"/>
-          <a:lstStyle/>
-          <a:p>
-            <a:pPr indent="0" marL="0">
-              <a:buNone/>
-            </a:pPr>
-            <a:r>
-              <a:rPr lang="en-US" sz="1100" dirty="0">
-                <a:solidFill>
-                  <a:srgbClr val="5B6B82"/>
-                </a:solidFill>
-                <a:latin typeface="Calibri" pitchFamily="34" charset="0"/>
-                <a:ea typeface="Calibri" pitchFamily="34" charset="-122"/>
-                <a:cs typeface="Calibri" pitchFamily="34" charset="-120"/>
-              </a:rPr>
-              <a:t>dizer meu nome e perguntar o nome de alguém</a:t>
-            </a:r>
-            <a:endParaRPr lang="en-US" sz="1100" dirty="0"/>
-          </a:p>
-        </p:txBody>
-      </p:sp>
-      <p:sp>
-        <p:nvSpPr>
-          <p:cNvPr id="28" name="Box"/>
-          <p:cNvSpPr/>
-          <p:nvPr/>
-        </p:nvSpPr>
-        <p:spPr>
-          <a:xfrm>
-            <a:off x="548640" y="7818120"/>
-            <a:ext cx="3172968" cy="1078992"/>
-          </a:xfrm>
-          <a:prstGeom prst="roundRect">
-            <a:avLst>
-              <a:gd name="adj" fmla="val 8475"/>
-            </a:avLst>
-          </a:prstGeom>
-          <a:solidFill>
-            <a:srgbClr val="E2F7EE"/>
-          </a:solidFill>
-          <a:ln w="12700">
-            <a:solidFill>
-              <a:srgbClr val="D5DCE8"/>
-            </a:solidFill>
-            <a:prstDash val="solid"/>
-          </a:ln>
-        </p:spPr>
-      </p:sp>
-      <p:sp>
-        <p:nvSpPr>
-          <p:cNvPr id="29" name="Badge"/>
-          <p:cNvSpPr/>
-          <p:nvPr/>
-        </p:nvSpPr>
-        <p:spPr>
-          <a:xfrm>
-            <a:off x="685800" y="8092440"/>
-            <a:ext cx="530352" cy="530352"/>
-          </a:xfrm>
-          <a:prstGeom prst="ellipse">
-            <a:avLst/>
-          </a:prstGeom>
-          <a:solidFill>
-            <a:srgbClr val="FFFFFF"/>
-          </a:solidFill>
-          <a:ln w="12700">
-            <a:solidFill>
-              <a:srgbClr val="FFFFFF"/>
-            </a:solidFill>
-            <a:prstDash val="solid"/>
-          </a:ln>
-        </p:spPr>
-      </p:sp>
-      <p:pic>
-        <p:nvPicPr>
-          <p:cNvPr id="30" name="Image 5" descr="Say where I'm from">    </p:cNvPr>
-          <p:cNvPicPr>
-            <a:picLocks noChangeAspect="1"/>
-          </p:cNvPicPr>
-          <p:nvPr/>
-        </p:nvPicPr>
-        <p:blipFill>
-          <a:blip r:embed="rId6"/>
-          <a:stretch>
-            <a:fillRect/>
-          </a:stretch>
-        </p:blipFill>
-        <p:spPr>
-          <a:xfrm>
-            <a:off x="813816" y="8220456"/>
-            <a:ext cx="274320" cy="274320"/>
-          </a:xfrm>
-          <a:prstGeom prst="rect">
-            <a:avLst/>
-          </a:prstGeom>
-        </p:spPr>
-      </p:pic>
-      <p:sp>
-        <p:nvSpPr>
-          <p:cNvPr id="31" name="Text 23"/>
-          <p:cNvSpPr txBox="1"/>
-          <p:nvPr/>
-        </p:nvSpPr>
-        <p:spPr>
-          <a:xfrm>
-            <a:off x="1371600" y="7927848"/>
-            <a:ext cx="2286000" cy="320040"/>
-          </a:xfrm>
-          <a:prstGeom prst="rect">
-            <a:avLst/>
-          </a:prstGeom>
-          <a:noFill/>
-          <a:ln/>
-        </p:spPr>
-        <p:txBody>
-          <a:bodyPr wrap="square" lIns="0" tIns="0" rIns="0" bIns="0" rtlCol="0" anchor="ctr"/>
-          <a:lstStyle/>
-          <a:p>
-            <a:pPr indent="0" marL="0">
-              <a:buNone/>
-            </a:pPr>
-            <a:r>
-              <a:rPr lang="en-US" sz="1800" b="1" dirty="0">
-                <a:solidFill>
-                  <a:srgbClr val="001737"/>
-                </a:solidFill>
-                <a:latin typeface="Arial Narrow" pitchFamily="34" charset="0"/>
-                <a:ea typeface="Arial Narrow" pitchFamily="34" charset="-122"/>
-                <a:cs typeface="Arial Narrow" pitchFamily="34" charset="-120"/>
-              </a:rPr>
-              <a:t>Say where I'm from</a:t>
-            </a:r>
-            <a:endParaRPr lang="en-US" sz="1800" dirty="0"/>
-          </a:p>
-        </p:txBody>
-      </p:sp>
-      <p:sp>
-        <p:nvSpPr>
-          <p:cNvPr id="32" name="Text 24"/>
-          <p:cNvSpPr txBox="1"/>
-          <p:nvPr/>
-        </p:nvSpPr>
-        <p:spPr>
-          <a:xfrm>
-            <a:off x="1371600" y="8275320"/>
-            <a:ext cx="2240280" cy="548640"/>
-          </a:xfrm>
-          <a:prstGeom prst="rect">
-            <a:avLst/>
-          </a:prstGeom>
-          <a:noFill/>
-          <a:ln/>
-        </p:spPr>
-        <p:txBody>
-          <a:bodyPr wrap="square" lIns="0" tIns="0" rIns="0" bIns="0" rtlCol="0" anchor="t"/>
-          <a:lstStyle/>
-          <a:p>
-            <a:pPr indent="0" marL="0">
-              <a:buNone/>
-            </a:pPr>
-            <a:r>
-              <a:rPr lang="en-US" sz="1100" dirty="0">
-                <a:solidFill>
-                  <a:srgbClr val="5B6B82"/>
-                </a:solidFill>
-                <a:latin typeface="Calibri" pitchFamily="34" charset="0"/>
-                <a:ea typeface="Calibri" pitchFamily="34" charset="-122"/>
-                <a:cs typeface="Calibri" pitchFamily="34" charset="-120"/>
-              </a:rPr>
-              <a:t>dizer meu país, nacionalidade e profissão</a:t>
-            </a:r>
-            <a:endParaRPr lang="en-US" sz="1100" dirty="0"/>
-          </a:p>
-        </p:txBody>
-      </p:sp>
-      <p:sp>
-        <p:nvSpPr>
-          <p:cNvPr id="33" name="Box"/>
-          <p:cNvSpPr/>
-          <p:nvPr/>
-        </p:nvSpPr>
-        <p:spPr>
-          <a:xfrm>
-            <a:off x="3840480" y="7818120"/>
-            <a:ext cx="3172968" cy="1078992"/>
-          </a:xfrm>
-          <a:prstGeom prst="roundRect">
-            <a:avLst>
-              <a:gd name="adj" fmla="val 8475"/>
-            </a:avLst>
-          </a:prstGeom>
-          <a:solidFill>
-            <a:srgbClr val="EFEAFE"/>
-          </a:solidFill>
-          <a:ln w="12700">
-            <a:solidFill>
-              <a:srgbClr val="D5DCE8"/>
-            </a:solidFill>
-            <a:prstDash val="solid"/>
-          </a:ln>
-        </p:spPr>
-      </p:sp>
-      <p:sp>
-        <p:nvSpPr>
-          <p:cNvPr id="34" name="Badge"/>
-          <p:cNvSpPr/>
-          <p:nvPr/>
-        </p:nvSpPr>
-        <p:spPr>
-          <a:xfrm>
-            <a:off x="3977640" y="8092440"/>
-            <a:ext cx="530352" cy="530352"/>
-          </a:xfrm>
-          <a:prstGeom prst="ellipse">
-            <a:avLst/>
-          </a:prstGeom>
-          <a:solidFill>
-            <a:srgbClr val="FFFFFF"/>
-          </a:solidFill>
-          <a:ln w="12700">
-            <a:solidFill>
-              <a:srgbClr val="FFFFFF"/>
-            </a:solidFill>
-            <a:prstDash val="solid"/>
-          </a:ln>
-        </p:spPr>
-      </p:sp>
-      <p:pic>
-        <p:nvPicPr>
-          <p:cNvPr id="35" name="Image 6" descr="Spell words">    </p:cNvPr>
-          <p:cNvPicPr>
-            <a:picLocks noChangeAspect="1"/>
-          </p:cNvPicPr>
-          <p:nvPr/>
-        </p:nvPicPr>
-        <p:blipFill>
-          <a:blip r:embed="rId7"/>
-          <a:stretch>
-            <a:fillRect/>
-          </a:stretch>
-        </p:blipFill>
-        <p:spPr>
-          <a:xfrm>
-            <a:off x="4105656" y="8220456"/>
-            <a:ext cx="274320" cy="274320"/>
-          </a:xfrm>
-          <a:prstGeom prst="rect">
-            <a:avLst/>
-          </a:prstGeom>
-        </p:spPr>
-      </p:pic>
-      <p:sp>
-        <p:nvSpPr>
-          <p:cNvPr id="36" name="Text 27"/>
-          <p:cNvSpPr txBox="1"/>
-          <p:nvPr/>
-        </p:nvSpPr>
-        <p:spPr>
-          <a:xfrm>
-            <a:off x="4663440" y="7927848"/>
-            <a:ext cx="2286000" cy="320040"/>
-          </a:xfrm>
-          <a:prstGeom prst="rect">
-            <a:avLst/>
-          </a:prstGeom>
-          <a:noFill/>
-          <a:ln/>
-        </p:spPr>
-        <p:txBody>
-          <a:bodyPr wrap="square" lIns="0" tIns="0" rIns="0" bIns="0" rtlCol="0" anchor="ctr"/>
-          <a:lstStyle/>
-          <a:p>
-            <a:pPr indent="0" marL="0">
-              <a:buNone/>
-            </a:pPr>
-            <a:r>
-              <a:rPr lang="en-US" sz="1800" b="1" dirty="0">
-                <a:solidFill>
-                  <a:srgbClr val="001737"/>
-                </a:solidFill>
-                <a:latin typeface="Arial Narrow" pitchFamily="34" charset="0"/>
-                <a:ea typeface="Arial Narrow" pitchFamily="34" charset="-122"/>
-                <a:cs typeface="Arial Narrow" pitchFamily="34" charset="-120"/>
-              </a:rPr>
-              <a:t>Spell words</a:t>
-            </a:r>
-            <a:endParaRPr lang="en-US" sz="1800" dirty="0"/>
-          </a:p>
-        </p:txBody>
-      </p:sp>
-      <p:sp>
-        <p:nvSpPr>
-          <p:cNvPr id="37" name="Text 28"/>
+          <p:cNvPr id="28" name="Text 21"/>
           <p:cNvSpPr txBox="1"/>
           <p:nvPr/>
         </p:nvSpPr>
@@ -3133,7 +2948,7 @@
       </p:sp>
       <p:sp>
         <p:nvSpPr>
-          <p:cNvPr id="38" name="Pill"/>
+          <p:cNvPr id="29" name="Pill"/>
           <p:cNvSpPr/>
           <p:nvPr/>
         </p:nvSpPr>
@@ -3160,7 +2975,7 @@
       </p:sp>
       <p:sp>
         <p:nvSpPr>
-          <p:cNvPr id="39" name="Text 30"/>
+          <p:cNvPr id="30" name="Text 23"/>
           <p:cNvSpPr txBox="1"/>
           <p:nvPr/>
         </p:nvSpPr>
@@ -3199,7 +3014,7 @@
       </p:sp>
       <p:sp>
         <p:nvSpPr>
-          <p:cNvPr id="40" name="Text 31"/>
+          <p:cNvPr id="31" name="Text 24"/>
           <p:cNvSpPr txBox="1"/>
           <p:nvPr/>
         </p:nvSpPr>
@@ -3238,7 +3053,7 @@
       </p:sp>
       <p:sp>
         <p:nvSpPr>
-          <p:cNvPr id="41" name="Pill"/>
+          <p:cNvPr id="32" name="Pill"/>
           <p:cNvSpPr/>
           <p:nvPr/>
         </p:nvSpPr>
@@ -3265,7 +3080,7 @@
       </p:sp>
       <p:sp>
         <p:nvSpPr>
-          <p:cNvPr id="42" name="Text 33"/>
+          <p:cNvPr id="33" name="Text 26"/>
           <p:cNvSpPr txBox="1"/>
           <p:nvPr/>
         </p:nvSpPr>
@@ -3304,7 +3119,7 @@
       </p:sp>
       <p:sp>
         <p:nvSpPr>
-          <p:cNvPr id="43" name="Text 34"/>
+          <p:cNvPr id="34" name="Text 27"/>
           <p:cNvSpPr txBox="1"/>
           <p:nvPr/>
         </p:nvSpPr>
@@ -3343,7 +3158,7 @@
       </p:sp>
       <p:sp>
         <p:nvSpPr>
-          <p:cNvPr id="44" name="Pill"/>
+          <p:cNvPr id="35" name="Pill"/>
           <p:cNvSpPr/>
           <p:nvPr/>
         </p:nvSpPr>
@@ -3370,7 +3185,7 @@
       </p:sp>
       <p:sp>
         <p:nvSpPr>
-          <p:cNvPr id="45" name="Text 36"/>
+          <p:cNvPr id="36" name="Text 29"/>
           <p:cNvSpPr txBox="1"/>
           <p:nvPr/>
         </p:nvSpPr>
@@ -3409,7 +3224,7 @@
       </p:sp>
       <p:sp>
         <p:nvSpPr>
-          <p:cNvPr id="46" name="Text 37"/>
+          <p:cNvPr id="37" name="Text 30"/>
           <p:cNvSpPr txBox="1"/>
           <p:nvPr/>
         </p:nvSpPr>
@@ -7511,6 +7326,853 @@
 </p:sld>
 </file>
 
+<file path=ppt/slides/slide12.xml><?xml version="1.0" encoding="utf-8"?>
+<p:sld xmlns:a="http://schemas.openxmlformats.org/drawingml/2006/main" xmlns:r="http://schemas.openxmlformats.org/officeDocument/2006/relationships" xmlns:p="http://schemas.openxmlformats.org/presentationml/2006/main">
+  <p:cSld name="Slide 12">
+    <p:spTree>
+      <p:nvGrpSpPr>
+        <p:cNvPr id="1" name=""/>
+        <p:cNvGrpSpPr/>
+        <p:nvPr/>
+      </p:nvGrpSpPr>
+      <p:grpSpPr>
+        <a:xfrm>
+          <a:off x="0" y="0"/>
+          <a:ext cx="0" cy="0"/>
+          <a:chOff x="0" y="0"/>
+          <a:chExt cx="0" cy="0"/>
+        </a:xfrm>
+      </p:grpSpPr>
+      <p:sp>
+        <p:nvSpPr>
+          <p:cNvPr id="2" name="Section number"/>
+          <p:cNvSpPr/>
+          <p:nvPr/>
+        </p:nvSpPr>
+        <p:spPr>
+          <a:xfrm>
+            <a:off x="548640" y="411480"/>
+            <a:ext cx="310896" cy="274320"/>
+          </a:xfrm>
+          <a:prstGeom prst="roundRect">
+            <a:avLst>
+              <a:gd name="adj" fmla="val 20000"/>
+            </a:avLst>
+          </a:prstGeom>
+          <a:solidFill>
+            <a:srgbClr val="001737"/>
+          </a:solidFill>
+          <a:ln w="12700">
+            <a:solidFill>
+              <a:srgbClr val="001737"/>
+            </a:solidFill>
+            <a:prstDash val="solid"/>
+          </a:ln>
+        </p:spPr>
+      </p:sp>
+      <p:sp>
+        <p:nvSpPr>
+          <p:cNvPr id="3" name="Text 1"/>
+          <p:cNvSpPr txBox="1"/>
+          <p:nvPr/>
+        </p:nvSpPr>
+        <p:spPr>
+          <a:xfrm>
+            <a:off x="548640" y="411480"/>
+            <a:ext cx="310896" cy="274320"/>
+          </a:xfrm>
+          <a:prstGeom prst="rect">
+            <a:avLst/>
+          </a:prstGeom>
+          <a:noFill/>
+          <a:ln/>
+        </p:spPr>
+        <p:txBody>
+          <a:bodyPr wrap="square" lIns="0" tIns="0" rIns="0" bIns="0" rtlCol="0" anchor="ctr"/>
+          <a:lstStyle/>
+          <a:p>
+            <a:pPr algn="ctr" indent="0" marL="0">
+              <a:buNone/>
+            </a:pPr>
+            <a:r>
+              <a:rPr lang="en-US" sz="1300" b="1" dirty="0">
+                <a:solidFill>
+                  <a:srgbClr val="FFCD04"/>
+                </a:solidFill>
+                <a:latin typeface="Calibri" pitchFamily="34" charset="0"/>
+                <a:ea typeface="Calibri" pitchFamily="34" charset="-122"/>
+                <a:cs typeface="Calibri" pitchFamily="34" charset="-120"/>
+              </a:rPr>
+              <a:t>★</a:t>
+            </a:r>
+            <a:endParaRPr lang="en-US" sz="1300" dirty="0"/>
+          </a:p>
+        </p:txBody>
+      </p:sp>
+      <p:sp>
+        <p:nvSpPr>
+          <p:cNvPr id="4" name="Section tab"/>
+          <p:cNvSpPr/>
+          <p:nvPr/>
+        </p:nvSpPr>
+        <p:spPr>
+          <a:xfrm>
+            <a:off x="896112" y="411480"/>
+            <a:ext cx="2103120" cy="274320"/>
+          </a:xfrm>
+          <a:prstGeom prst="roundRect">
+            <a:avLst>
+              <a:gd name="adj" fmla="val 20000"/>
+            </a:avLst>
+          </a:prstGeom>
+          <a:solidFill>
+            <a:srgbClr val="FFCD04"/>
+          </a:solidFill>
+          <a:ln w="12700">
+            <a:solidFill>
+              <a:srgbClr val="FFCD04"/>
+            </a:solidFill>
+            <a:prstDash val="solid"/>
+          </a:ln>
+        </p:spPr>
+      </p:sp>
+      <p:sp>
+        <p:nvSpPr>
+          <p:cNvPr id="5" name="Text 3"/>
+          <p:cNvSpPr txBox="1"/>
+          <p:nvPr/>
+        </p:nvSpPr>
+        <p:spPr>
+          <a:xfrm>
+            <a:off x="896112" y="411480"/>
+            <a:ext cx="2103120" cy="274320"/>
+          </a:xfrm>
+          <a:prstGeom prst="rect">
+            <a:avLst/>
+          </a:prstGeom>
+          <a:noFill/>
+          <a:ln/>
+        </p:spPr>
+        <p:txBody>
+          <a:bodyPr wrap="square" lIns="0" tIns="0" rIns="0" bIns="0" rtlCol="0" anchor="ctr"/>
+          <a:lstStyle/>
+          <a:p>
+            <a:pPr algn="ctr" indent="0" marL="0">
+              <a:buNone/>
+            </a:pPr>
+            <a:r>
+              <a:rPr lang="en-US" sz="1100" b="1" spc="200" kern="0" dirty="0">
+                <a:solidFill>
+                  <a:srgbClr val="001737"/>
+                </a:solidFill>
+                <a:latin typeface="Calibri" pitchFamily="34" charset="0"/>
+                <a:ea typeface="Calibri" pitchFamily="34" charset="-122"/>
+                <a:cs typeface="Calibri" pitchFamily="34" charset="-120"/>
+              </a:rPr>
+              <a:t>APPENDIX</a:t>
+            </a:r>
+            <a:endParaRPr lang="en-US" sz="1100" dirty="0"/>
+          </a:p>
+        </p:txBody>
+      </p:sp>
+      <p:sp>
+        <p:nvSpPr>
+          <p:cNvPr id="6" name="Title"/>
+          <p:cNvSpPr txBox="1"/>
+          <p:nvPr/>
+        </p:nvSpPr>
+        <p:spPr>
+          <a:xfrm>
+            <a:off x="548640" y="740664"/>
+            <a:ext cx="6464808" cy="457200"/>
+          </a:xfrm>
+          <a:prstGeom prst="rect">
+            <a:avLst/>
+          </a:prstGeom>
+          <a:noFill/>
+          <a:ln/>
+        </p:spPr>
+        <p:txBody>
+          <a:bodyPr wrap="square" lIns="0" tIns="0" rIns="0" bIns="0" rtlCol="0" anchor="ctr"/>
+          <a:lstStyle/>
+          <a:p>
+            <a:pPr indent="0" marL="0">
+              <a:buNone/>
+            </a:pPr>
+            <a:r>
+              <a:rPr lang="en-US" sz="2600" b="1" dirty="0">
+                <a:solidFill>
+                  <a:srgbClr val="001737"/>
+                </a:solidFill>
+                <a:latin typeface="Arial Narrow" pitchFamily="34" charset="0"/>
+                <a:ea typeface="Arial Narrow" pitchFamily="34" charset="-122"/>
+                <a:cs typeface="Arial Narrow" pitchFamily="34" charset="-120"/>
+              </a:rPr>
+              <a:t>Photo credits</a:t>
+            </a:r>
+            <a:endParaRPr lang="en-US" sz="2600" dirty="0"/>
+          </a:p>
+        </p:txBody>
+      </p:sp>
+      <p:sp>
+        <p:nvSpPr>
+          <p:cNvPr id="7" name="Text 5"/>
+          <p:cNvSpPr txBox="1"/>
+          <p:nvPr/>
+        </p:nvSpPr>
+        <p:spPr>
+          <a:xfrm>
+            <a:off x="548640" y="1280160"/>
+            <a:ext cx="6464808" cy="457200"/>
+          </a:xfrm>
+          <a:prstGeom prst="rect">
+            <a:avLst/>
+          </a:prstGeom>
+          <a:noFill/>
+          <a:ln/>
+        </p:spPr>
+        <p:txBody>
+          <a:bodyPr wrap="square" lIns="0" tIns="0" rIns="0" bIns="0" rtlCol="0" anchor="t"/>
+          <a:lstStyle/>
+          <a:p>
+            <a:pPr indent="0" marL="0">
+              <a:buNone/>
+            </a:pPr>
+            <a:r>
+              <a:rPr lang="en-US" sz="1200" dirty="0">
+                <a:solidFill>
+                  <a:srgbClr val="5B6B82"/>
+                </a:solidFill>
+                <a:latin typeface="Calibri" pitchFamily="34" charset="0"/>
+                <a:ea typeface="Calibri" pitchFamily="34" charset="-122"/>
+                <a:cs typeface="Calibri" pitchFamily="34" charset="-120"/>
+              </a:rPr>
+              <a:t>Fotos de licença livre (Wikimedia Commons). Ao reutilizar, mantenha o crédito e a licença.</a:t>
+            </a:r>
+            <a:endParaRPr lang="en-US" sz="1200" dirty="0"/>
+          </a:p>
+        </p:txBody>
+      </p:sp>
+      <p:sp>
+        <p:nvSpPr>
+          <p:cNvPr id="8" name="Box"/>
+          <p:cNvSpPr/>
+          <p:nvPr/>
+        </p:nvSpPr>
+        <p:spPr>
+          <a:xfrm>
+            <a:off x="548640" y="1828800"/>
+            <a:ext cx="6464808" cy="749808"/>
+          </a:xfrm>
+          <a:prstGeom prst="roundRect">
+            <a:avLst>
+              <a:gd name="adj" fmla="val 12195"/>
+            </a:avLst>
+          </a:prstGeom>
+          <a:solidFill>
+            <a:srgbClr val="F3F6FB"/>
+          </a:solidFill>
+          <a:ln w="12700">
+            <a:solidFill>
+              <a:srgbClr val="D5DCE8"/>
+            </a:solidFill>
+            <a:prstDash val="solid"/>
+          </a:ln>
+        </p:spPr>
+      </p:sp>
+      <p:sp>
+        <p:nvSpPr>
+          <p:cNvPr id="9" name="Text 7"/>
+          <p:cNvSpPr txBox="1"/>
+          <p:nvPr/>
+        </p:nvSpPr>
+        <p:spPr>
+          <a:xfrm>
+            <a:off x="685800" y="1901952"/>
+            <a:ext cx="6126480" cy="256032"/>
+          </a:xfrm>
+          <a:prstGeom prst="rect">
+            <a:avLst/>
+          </a:prstGeom>
+          <a:noFill/>
+          <a:ln/>
+        </p:spPr>
+        <p:txBody>
+          <a:bodyPr wrap="square" lIns="0" tIns="0" rIns="0" bIns="0" rtlCol="0" anchor="t"/>
+          <a:lstStyle/>
+          <a:p>
+            <a:pPr indent="0" marL="0">
+              <a:buNone/>
+            </a:pPr>
+            <a:r>
+              <a:rPr lang="en-US" sz="1200" b="1" dirty="0">
+                <a:solidFill>
+                  <a:srgbClr val="001737"/>
+                </a:solidFill>
+                <a:latin typeface="Calibri" pitchFamily="34" charset="0"/>
+                <a:ea typeface="Calibri" pitchFamily="34" charset="-122"/>
+                <a:cs typeface="Calibri" pitchFamily="34" charset="-120"/>
+              </a:rPr>
+              <a:t>Cover</a:t>
+            </a:r>
+            <a:endParaRPr lang="en-US" sz="1200" dirty="0"/>
+          </a:p>
+        </p:txBody>
+      </p:sp>
+      <p:sp>
+        <p:nvSpPr>
+          <p:cNvPr id="10" name="Text 8"/>
+          <p:cNvSpPr txBox="1"/>
+          <p:nvPr/>
+        </p:nvSpPr>
+        <p:spPr>
+          <a:xfrm>
+            <a:off x="685800" y="2176272"/>
+            <a:ext cx="6126480" cy="347472"/>
+          </a:xfrm>
+          <a:prstGeom prst="rect">
+            <a:avLst/>
+          </a:prstGeom>
+          <a:noFill/>
+          <a:ln/>
+        </p:spPr>
+        <p:txBody>
+          <a:bodyPr wrap="square" lIns="0" tIns="0" rIns="0" bIns="0" rtlCol="0" anchor="t"/>
+          <a:lstStyle/>
+          <a:p>
+            <a:pPr indent="0" marL="0">
+              <a:buNone/>
+            </a:pPr>
+            <a:r>
+              <a:rPr lang="en-US" sz="1050" dirty="0">
+                <a:solidFill>
+                  <a:srgbClr val="5B6B82"/>
+                </a:solidFill>
+                <a:latin typeface="Calibri" pitchFamily="34" charset="0"/>
+                <a:ea typeface="Calibri" pitchFamily="34" charset="-122"/>
+                <a:cs typeface="Calibri" pitchFamily="34" charset="-120"/>
+              </a:rPr>
+              <a:t>Business man and woman handshake in work office · perzon seo · CC BY 2.0</a:t>
+            </a:r>
+            <a:endParaRPr lang="en-US" sz="1050" dirty="0"/>
+          </a:p>
+        </p:txBody>
+      </p:sp>
+      <p:sp>
+        <p:nvSpPr>
+          <p:cNvPr id="11" name="Box"/>
+          <p:cNvSpPr/>
+          <p:nvPr/>
+        </p:nvSpPr>
+        <p:spPr>
+          <a:xfrm>
+            <a:off x="548640" y="2697480"/>
+            <a:ext cx="6464808" cy="749808"/>
+          </a:xfrm>
+          <a:prstGeom prst="roundRect">
+            <a:avLst>
+              <a:gd name="adj" fmla="val 12195"/>
+            </a:avLst>
+          </a:prstGeom>
+          <a:solidFill>
+            <a:srgbClr val="FFFFFF"/>
+          </a:solidFill>
+          <a:ln w="12700">
+            <a:solidFill>
+              <a:srgbClr val="D5DCE8"/>
+            </a:solidFill>
+            <a:prstDash val="solid"/>
+          </a:ln>
+        </p:spPr>
+      </p:sp>
+      <p:sp>
+        <p:nvSpPr>
+          <p:cNvPr id="12" name="Text 10"/>
+          <p:cNvSpPr txBox="1"/>
+          <p:nvPr/>
+        </p:nvSpPr>
+        <p:spPr>
+          <a:xfrm>
+            <a:off x="685800" y="2770632"/>
+            <a:ext cx="6126480" cy="256032"/>
+          </a:xfrm>
+          <a:prstGeom prst="rect">
+            <a:avLst/>
+          </a:prstGeom>
+          <a:noFill/>
+          <a:ln/>
+        </p:spPr>
+        <p:txBody>
+          <a:bodyPr wrap="square" lIns="0" tIns="0" rIns="0" bIns="0" rtlCol="0" anchor="t"/>
+          <a:lstStyle/>
+          <a:p>
+            <a:pPr indent="0" marL="0">
+              <a:buNone/>
+            </a:pPr>
+            <a:r>
+              <a:rPr lang="en-US" sz="1200" b="1" dirty="0">
+                <a:solidFill>
+                  <a:srgbClr val="001737"/>
+                </a:solidFill>
+                <a:latin typeface="Calibri" pitchFamily="34" charset="0"/>
+                <a:ea typeface="Calibri" pitchFamily="34" charset="-122"/>
+                <a:cs typeface="Calibri" pitchFamily="34" charset="-120"/>
+              </a:rPr>
+              <a:t>Warm-up a (8:00 p.m.)</a:t>
+            </a:r>
+            <a:endParaRPr lang="en-US" sz="1200" dirty="0"/>
+          </a:p>
+        </p:txBody>
+      </p:sp>
+      <p:sp>
+        <p:nvSpPr>
+          <p:cNvPr id="13" name="Text 11"/>
+          <p:cNvSpPr txBox="1"/>
+          <p:nvPr/>
+        </p:nvSpPr>
+        <p:spPr>
+          <a:xfrm>
+            <a:off x="685800" y="3044952"/>
+            <a:ext cx="6126480" cy="347472"/>
+          </a:xfrm>
+          <a:prstGeom prst="rect">
+            <a:avLst/>
+          </a:prstGeom>
+          <a:noFill/>
+          <a:ln/>
+        </p:spPr>
+        <p:txBody>
+          <a:bodyPr wrap="square" lIns="0" tIns="0" rIns="0" bIns="0" rtlCol="0" anchor="t"/>
+          <a:lstStyle/>
+          <a:p>
+            <a:pPr indent="0" marL="0">
+              <a:buNone/>
+            </a:pPr>
+            <a:r>
+              <a:rPr lang="en-US" sz="1050" dirty="0">
+                <a:solidFill>
+                  <a:srgbClr val="5B6B82"/>
+                </a:solidFill>
+                <a:latin typeface="Calibri" pitchFamily="34" charset="0"/>
+                <a:ea typeface="Calibri" pitchFamily="34" charset="-122"/>
+                <a:cs typeface="Calibri" pitchFamily="34" charset="-120"/>
+              </a:rPr>
+              <a:t>CentralBusinessDistrict-skyline-Singapore-20090213 · Kok Leng Yeo · CC BY 2.0</a:t>
+            </a:r>
+            <a:endParaRPr lang="en-US" sz="1050" dirty="0"/>
+          </a:p>
+        </p:txBody>
+      </p:sp>
+      <p:sp>
+        <p:nvSpPr>
+          <p:cNvPr id="14" name="Box"/>
+          <p:cNvSpPr/>
+          <p:nvPr/>
+        </p:nvSpPr>
+        <p:spPr>
+          <a:xfrm>
+            <a:off x="548640" y="3566160"/>
+            <a:ext cx="6464808" cy="749808"/>
+          </a:xfrm>
+          <a:prstGeom prst="roundRect">
+            <a:avLst>
+              <a:gd name="adj" fmla="val 12195"/>
+            </a:avLst>
+          </a:prstGeom>
+          <a:solidFill>
+            <a:srgbClr val="F3F6FB"/>
+          </a:solidFill>
+          <a:ln w="12700">
+            <a:solidFill>
+              <a:srgbClr val="D5DCE8"/>
+            </a:solidFill>
+            <a:prstDash val="solid"/>
+          </a:ln>
+        </p:spPr>
+      </p:sp>
+      <p:sp>
+        <p:nvSpPr>
+          <p:cNvPr id="15" name="Text 13"/>
+          <p:cNvSpPr txBox="1"/>
+          <p:nvPr/>
+        </p:nvSpPr>
+        <p:spPr>
+          <a:xfrm>
+            <a:off x="685800" y="3639312"/>
+            <a:ext cx="6126480" cy="256032"/>
+          </a:xfrm>
+          <a:prstGeom prst="rect">
+            <a:avLst/>
+          </a:prstGeom>
+          <a:noFill/>
+          <a:ln/>
+        </p:spPr>
+        <p:txBody>
+          <a:bodyPr wrap="square" lIns="0" tIns="0" rIns="0" bIns="0" rtlCol="0" anchor="t"/>
+          <a:lstStyle/>
+          <a:p>
+            <a:pPr indent="0" marL="0">
+              <a:buNone/>
+            </a:pPr>
+            <a:r>
+              <a:rPr lang="en-US" sz="1200" b="1" dirty="0">
+                <a:solidFill>
+                  <a:srgbClr val="001737"/>
+                </a:solidFill>
+                <a:latin typeface="Calibri" pitchFamily="34" charset="0"/>
+                <a:ea typeface="Calibri" pitchFamily="34" charset="-122"/>
+                <a:cs typeface="Calibri" pitchFamily="34" charset="-120"/>
+              </a:rPr>
+              <a:t>Warm-up b (7:00 a.m.)</a:t>
+            </a:r>
+            <a:endParaRPr lang="en-US" sz="1200" dirty="0"/>
+          </a:p>
+        </p:txBody>
+      </p:sp>
+      <p:sp>
+        <p:nvSpPr>
+          <p:cNvPr id="16" name="Text 14"/>
+          <p:cNvSpPr txBox="1"/>
+          <p:nvPr/>
+        </p:nvSpPr>
+        <p:spPr>
+          <a:xfrm>
+            <a:off x="685800" y="3913632"/>
+            <a:ext cx="6126480" cy="347472"/>
+          </a:xfrm>
+          <a:prstGeom prst="rect">
+            <a:avLst/>
+          </a:prstGeom>
+          <a:noFill/>
+          <a:ln/>
+        </p:spPr>
+        <p:txBody>
+          <a:bodyPr wrap="square" lIns="0" tIns="0" rIns="0" bIns="0" rtlCol="0" anchor="t"/>
+          <a:lstStyle/>
+          <a:p>
+            <a:pPr indent="0" marL="0">
+              <a:buNone/>
+            </a:pPr>
+            <a:r>
+              <a:rPr lang="en-US" sz="1050" dirty="0">
+                <a:solidFill>
+                  <a:srgbClr val="5B6B82"/>
+                </a:solidFill>
+                <a:latin typeface="Calibri" pitchFamily="34" charset="0"/>
+                <a:ea typeface="Calibri" pitchFamily="34" charset="-122"/>
+                <a:cs typeface="Calibri" pitchFamily="34" charset="-120"/>
+              </a:rPr>
+              <a:t>Morning Sky - 22023851233 · Susanne Nilsson · CC BY-SA 2.0</a:t>
+            </a:r>
+            <a:endParaRPr lang="en-US" sz="1050" dirty="0"/>
+          </a:p>
+        </p:txBody>
+      </p:sp>
+      <p:sp>
+        <p:nvSpPr>
+          <p:cNvPr id="17" name="Box"/>
+          <p:cNvSpPr/>
+          <p:nvPr/>
+        </p:nvSpPr>
+        <p:spPr>
+          <a:xfrm>
+            <a:off x="548640" y="4434840"/>
+            <a:ext cx="6464808" cy="749808"/>
+          </a:xfrm>
+          <a:prstGeom prst="roundRect">
+            <a:avLst>
+              <a:gd name="adj" fmla="val 12195"/>
+            </a:avLst>
+          </a:prstGeom>
+          <a:solidFill>
+            <a:srgbClr val="FFFFFF"/>
+          </a:solidFill>
+          <a:ln w="12700">
+            <a:solidFill>
+              <a:srgbClr val="D5DCE8"/>
+            </a:solidFill>
+            <a:prstDash val="solid"/>
+          </a:ln>
+        </p:spPr>
+      </p:sp>
+      <p:sp>
+        <p:nvSpPr>
+          <p:cNvPr id="18" name="Text 16"/>
+          <p:cNvSpPr txBox="1"/>
+          <p:nvPr/>
+        </p:nvSpPr>
+        <p:spPr>
+          <a:xfrm>
+            <a:off x="685800" y="4507992"/>
+            <a:ext cx="6126480" cy="256032"/>
+          </a:xfrm>
+          <a:prstGeom prst="rect">
+            <a:avLst/>
+          </a:prstGeom>
+          <a:noFill/>
+          <a:ln/>
+        </p:spPr>
+        <p:txBody>
+          <a:bodyPr wrap="square" lIns="0" tIns="0" rIns="0" bIns="0" rtlCol="0" anchor="t"/>
+          <a:lstStyle/>
+          <a:p>
+            <a:pPr indent="0" marL="0">
+              <a:buNone/>
+            </a:pPr>
+            <a:r>
+              <a:rPr lang="en-US" sz="1200" b="1" dirty="0">
+                <a:solidFill>
+                  <a:srgbClr val="001737"/>
+                </a:solidFill>
+                <a:latin typeface="Calibri" pitchFamily="34" charset="0"/>
+                <a:ea typeface="Calibri" pitchFamily="34" charset="-122"/>
+                <a:cs typeface="Calibri" pitchFamily="34" charset="-120"/>
+              </a:rPr>
+              <a:t>Warm-up c (11:00 p.m.)</a:t>
+            </a:r>
+            <a:endParaRPr lang="en-US" sz="1200" dirty="0"/>
+          </a:p>
+        </p:txBody>
+      </p:sp>
+      <p:sp>
+        <p:nvSpPr>
+          <p:cNvPr id="19" name="Text 17"/>
+          <p:cNvSpPr txBox="1"/>
+          <p:nvPr/>
+        </p:nvSpPr>
+        <p:spPr>
+          <a:xfrm>
+            <a:off x="685800" y="4782312"/>
+            <a:ext cx="6126480" cy="347472"/>
+          </a:xfrm>
+          <a:prstGeom prst="rect">
+            <a:avLst/>
+          </a:prstGeom>
+          <a:noFill/>
+          <a:ln/>
+        </p:spPr>
+        <p:txBody>
+          <a:bodyPr wrap="square" lIns="0" tIns="0" rIns="0" bIns="0" rtlCol="0" anchor="t"/>
+          <a:lstStyle/>
+          <a:p>
+            <a:pPr indent="0" marL="0">
+              <a:buNone/>
+            </a:pPr>
+            <a:r>
+              <a:rPr lang="en-US" sz="1050" dirty="0">
+                <a:solidFill>
+                  <a:srgbClr val="5B6B82"/>
+                </a:solidFill>
+                <a:latin typeface="Calibri" pitchFamily="34" charset="0"/>
+                <a:ea typeface="Calibri" pitchFamily="34" charset="-122"/>
+                <a:cs typeface="Calibri" pitchFamily="34" charset="-120"/>
+              </a:rPr>
+              <a:t>DSC 8585 Cozy elegant bedroom with a plush king-size bed · PattayaPatrol · CC BY-SA 4.0</a:t>
+            </a:r>
+            <a:endParaRPr lang="en-US" sz="1050" dirty="0"/>
+          </a:p>
+        </p:txBody>
+      </p:sp>
+      <p:sp>
+        <p:nvSpPr>
+          <p:cNvPr id="20" name="Box"/>
+          <p:cNvSpPr/>
+          <p:nvPr/>
+        </p:nvSpPr>
+        <p:spPr>
+          <a:xfrm>
+            <a:off x="548640" y="5303520"/>
+            <a:ext cx="6464808" cy="749808"/>
+          </a:xfrm>
+          <a:prstGeom prst="roundRect">
+            <a:avLst>
+              <a:gd name="adj" fmla="val 12195"/>
+            </a:avLst>
+          </a:prstGeom>
+          <a:solidFill>
+            <a:srgbClr val="F3F6FB"/>
+          </a:solidFill>
+          <a:ln w="12700">
+            <a:solidFill>
+              <a:srgbClr val="D5DCE8"/>
+            </a:solidFill>
+            <a:prstDash val="solid"/>
+          </a:ln>
+        </p:spPr>
+      </p:sp>
+      <p:sp>
+        <p:nvSpPr>
+          <p:cNvPr id="21" name="Text 19"/>
+          <p:cNvSpPr txBox="1"/>
+          <p:nvPr/>
+        </p:nvSpPr>
+        <p:spPr>
+          <a:xfrm>
+            <a:off x="685800" y="5376672"/>
+            <a:ext cx="6126480" cy="256032"/>
+          </a:xfrm>
+          <a:prstGeom prst="rect">
+            <a:avLst/>
+          </a:prstGeom>
+          <a:noFill/>
+          <a:ln/>
+        </p:spPr>
+        <p:txBody>
+          <a:bodyPr wrap="square" lIns="0" tIns="0" rIns="0" bIns="0" rtlCol="0" anchor="t"/>
+          <a:lstStyle/>
+          <a:p>
+            <a:pPr indent="0" marL="0">
+              <a:buNone/>
+            </a:pPr>
+            <a:r>
+              <a:rPr lang="en-US" sz="1200" b="1" dirty="0">
+                <a:solidFill>
+                  <a:srgbClr val="001737"/>
+                </a:solidFill>
+                <a:latin typeface="Calibri" pitchFamily="34" charset="0"/>
+                <a:ea typeface="Calibri" pitchFamily="34" charset="-122"/>
+                <a:cs typeface="Calibri" pitchFamily="34" charset="-120"/>
+              </a:rPr>
+              <a:t>Warm-up d (3:00 p.m.)</a:t>
+            </a:r>
+            <a:endParaRPr lang="en-US" sz="1200" dirty="0"/>
+          </a:p>
+        </p:txBody>
+      </p:sp>
+      <p:sp>
+        <p:nvSpPr>
+          <p:cNvPr id="22" name="Text 20"/>
+          <p:cNvSpPr txBox="1"/>
+          <p:nvPr/>
+        </p:nvSpPr>
+        <p:spPr>
+          <a:xfrm>
+            <a:off x="685800" y="5650992"/>
+            <a:ext cx="6126480" cy="347472"/>
+          </a:xfrm>
+          <a:prstGeom prst="rect">
+            <a:avLst/>
+          </a:prstGeom>
+          <a:noFill/>
+          <a:ln/>
+        </p:spPr>
+        <p:txBody>
+          <a:bodyPr wrap="square" lIns="0" tIns="0" rIns="0" bIns="0" rtlCol="0" anchor="t"/>
+          <a:lstStyle/>
+          <a:p>
+            <a:pPr indent="0" marL="0">
+              <a:buNone/>
+            </a:pPr>
+            <a:r>
+              <a:rPr lang="en-US" sz="1050" dirty="0">
+                <a:solidFill>
+                  <a:srgbClr val="5B6B82"/>
+                </a:solidFill>
+                <a:latin typeface="Calibri" pitchFamily="34" charset="0"/>
+                <a:ea typeface="Calibri" pitchFamily="34" charset="-122"/>
+                <a:cs typeface="Calibri" pitchFamily="34" charset="-120"/>
+              </a:rPr>
+              <a:t>A sunny August afternoon on Primrose Hill NW1 · Roger Davies · CC BY-SA 2.0</a:t>
+            </a:r>
+            <a:endParaRPr lang="en-US" sz="1050" dirty="0"/>
+          </a:p>
+        </p:txBody>
+      </p:sp>
+      <p:sp>
+        <p:nvSpPr>
+          <p:cNvPr id="23" name="Text 21"/>
+          <p:cNvSpPr txBox="1"/>
+          <p:nvPr/>
+        </p:nvSpPr>
+        <p:spPr>
+          <a:xfrm>
+            <a:off x="548640" y="6400800"/>
+            <a:ext cx="6464808" cy="548640"/>
+          </a:xfrm>
+          <a:prstGeom prst="rect">
+            <a:avLst/>
+          </a:prstGeom>
+          <a:noFill/>
+          <a:ln/>
+        </p:spPr>
+        <p:txBody>
+          <a:bodyPr wrap="square" lIns="0" tIns="0" rIns="0" bIns="0" rtlCol="0" anchor="t"/>
+          <a:lstStyle/>
+          <a:p>
+            <a:pPr indent="0" marL="0">
+              <a:buNone/>
+            </a:pPr>
+            <a:r>
+              <a:rPr lang="en-US" sz="1100" dirty="0">
+                <a:solidFill>
+                  <a:srgbClr val="5B6B82"/>
+                </a:solidFill>
+                <a:latin typeface="Calibri" pitchFamily="34" charset="0"/>
+                <a:ea typeface="Calibri" pitchFamily="34" charset="-122"/>
+                <a:cs typeface="Calibri" pitchFamily="34" charset="-120"/>
+              </a:rPr>
+              <a:t>Personagens, bandeiras e ícones: ilustrações originais da série. Fonte das fotos: commons.wikimedia.org (ver página de cada arquivo).</a:t>
+            </a:r>
+            <a:endParaRPr lang="en-US" sz="1100" dirty="0"/>
+          </a:p>
+        </p:txBody>
+      </p:sp>
+      <p:sp>
+        <p:nvSpPr>
+          <p:cNvPr id="25" name="Slide Number Placeholder 0"/>
+          <p:cNvSpPr>
+            <a:spLocks noGrp="1"/>
+          </p:cNvSpPr>
+          <p:nvPr>
+            <p:ph type="sldNum" sz="quarter" idx="4294967295"/>
+          </p:nvPr>
+        </p:nvSpPr>
+        <p:spPr>
+          <a:xfrm>
+            <a:off x="6556248" y="10241280"/>
+            <a:ext cx="457200" cy="201168"/>
+          </a:xfrm>
+          <a:prstGeom prst="rect">
+            <a:avLst/>
+          </a:prstGeom>
+          <a:extLst>
+            <a:ext uri="{C572A759-6A51-4108-AA02-DFA0A04FC94B}">
+              <ma14:wrappingTextBoxFlag xmlns:ma14="http://schemas.microsoft.com/office/mac/drawingml/2011/main" val="0"/>
+            </a:ext>
+          </a:extLst>
+        </p:spPr>
+        <p:txBody>
+          <a:bodyPr/>
+          <a:lstStyle>
+            <a:lvl1pPr>
+              <a:defRPr sz="1000">
+                <a:solidFill>
+                  <a:srgbClr val="5B6B82"/>
+                </a:solidFill>
+                <a:latin typeface="Calibri"/>
+                <a:ea typeface="Calibri"/>
+                <a:cs typeface="Calibri"/>
+              </a:defRPr>
+            </a:lvl1pPr>
+          </a:lstStyle>
+          <a:p>
+            <a:pPr algn="r"/>
+            <a:fld id="{F7021451-1387-4CA6-816F-3879F97B5CBC}" type="slidenum">
+              <a:rPr b="1" lang="en-US"/>
+              <a:t>12</a:t>
+            </a:fld>
+            <a:endParaRPr lang="en-US"/>
+          </a:p>
+        </p:txBody>
+      </p:sp>
+    </p:spTree>
+  </p:cSld>
+  <p:clrMapOvr>
+    <a:masterClrMapping/>
+  </p:clrMapOvr>
+</p:sld>
+</file>
+
 <file path=ppt/slides/slide2.xml><?xml version="1.0" encoding="utf-8"?>
 <p:sld xmlns:a="http://schemas.openxmlformats.org/drawingml/2006/main" xmlns:r="http://schemas.openxmlformats.org/officeDocument/2006/relationships" xmlns:p="http://schemas.openxmlformats.org/presentationml/2006/main">
   <p:cSld name="Slide 2">
@@ -7804,36 +8466,9 @@
           </a:p>
         </p:txBody>
       </p:sp>
-      <p:sp>
-        <p:nvSpPr>
-          <p:cNvPr id="10" name="Box"/>
-          <p:cNvSpPr/>
-          <p:nvPr/>
-        </p:nvSpPr>
-        <p:spPr>
-          <a:xfrm>
-            <a:off x="548640" y="1828800"/>
-            <a:ext cx="1508760" cy="1371600"/>
-          </a:xfrm>
-          <a:prstGeom prst="roundRect">
-            <a:avLst>
-              <a:gd name="adj" fmla="val 6667"/>
-            </a:avLst>
-          </a:prstGeom>
-          <a:solidFill>
-            <a:srgbClr val="EFEAFE"/>
-          </a:solidFill>
-          <a:ln w="12700">
-            <a:solidFill>
-              <a:srgbClr val="D5DCE8"/>
-            </a:solidFill>
-            <a:prstDash val="solid"/>
-          </a:ln>
-        </p:spPr>
-      </p:sp>
       <p:pic>
         <p:nvPicPr>
-          <p:cNvPr id="11" name="Image 0" descr="Time of day a">    </p:cNvPr>
+          <p:cNvPr id="10" name="Image 0" descr="warmup-a">    </p:cNvPr>
           <p:cNvPicPr>
             <a:picLocks noChangeAspect="1"/>
           </p:cNvPicPr>
@@ -7841,14 +8476,13 @@
         </p:nvPicPr>
         <p:blipFill>
           <a:blip r:embed="rId1"/>
-          <a:stretch>
-            <a:fillRect/>
-          </a:stretch>
+          <a:srcRect l="0" r="0" t="0" b="0"/>
+          <a:stretch/>
         </p:blipFill>
         <p:spPr>
           <a:xfrm>
-            <a:off x="1024128" y="2084832"/>
-            <a:ext cx="548640" cy="548640"/>
+            <a:off x="548640" y="1828800"/>
+            <a:ext cx="1508760" cy="1371600"/>
           </a:xfrm>
           <a:prstGeom prst="rect">
             <a:avLst/>
@@ -7857,7 +8491,7 @@
       </p:pic>
       <p:sp>
         <p:nvSpPr>
-          <p:cNvPr id="12" name="Pill"/>
+          <p:cNvPr id="11" name="Pill"/>
           <p:cNvSpPr/>
           <p:nvPr/>
         </p:nvSpPr>
@@ -7884,7 +8518,7 @@
       </p:sp>
       <p:sp>
         <p:nvSpPr>
-          <p:cNvPr id="13" name="Text 10"/>
+          <p:cNvPr id="12" name="Text 9"/>
           <p:cNvSpPr txBox="1"/>
           <p:nvPr/>
         </p:nvSpPr>
@@ -7923,73 +8557,73 @@
       </p:sp>
       <p:sp>
         <p:nvSpPr>
-          <p:cNvPr id="14" name="Text 11"/>
-          <p:cNvSpPr txBox="1"/>
-          <p:nvPr/>
-        </p:nvSpPr>
-        <p:spPr>
-          <a:xfrm>
-            <a:off x="548640" y="2788920"/>
-            <a:ext cx="1508760" cy="320040"/>
-          </a:xfrm>
-          <a:prstGeom prst="rect">
-            <a:avLst/>
-          </a:prstGeom>
-          <a:noFill/>
-          <a:ln/>
-        </p:spPr>
-        <p:txBody>
-          <a:bodyPr wrap="square" lIns="0" tIns="0" rIns="0" bIns="0" rtlCol="0" anchor="ctr"/>
-          <a:lstStyle/>
-          <a:p>
-            <a:pPr algn="ctr" indent="0" marL="0">
-              <a:buNone/>
-            </a:pPr>
-            <a:r>
-              <a:rPr lang="en-US" sz="1300" b="1" dirty="0">
-                <a:solidFill>
-                  <a:srgbClr val="001737"/>
-                </a:solidFill>
-                <a:latin typeface="Calibri" pitchFamily="34" charset="0"/>
-                <a:ea typeface="Calibri" pitchFamily="34" charset="-122"/>
-                <a:cs typeface="Calibri" pitchFamily="34" charset="-120"/>
-              </a:rPr>
-              <a:t>8:00 p.m.</a:t>
-            </a:r>
-            <a:endParaRPr lang="en-US" sz="1300" dirty="0"/>
-          </a:p>
-        </p:txBody>
-      </p:sp>
-      <p:sp>
-        <p:nvSpPr>
-          <p:cNvPr id="15" name="Box"/>
+          <p:cNvPr id="13" name="Pill"/>
           <p:cNvSpPr/>
           <p:nvPr/>
         </p:nvSpPr>
         <p:spPr>
           <a:xfrm>
-            <a:off x="2194560" y="1828800"/>
-            <a:ext cx="1508760" cy="1371600"/>
+            <a:off x="777240" y="2834640"/>
+            <a:ext cx="1051560" cy="274320"/>
           </a:xfrm>
           <a:prstGeom prst="roundRect">
             <a:avLst>
-              <a:gd name="adj" fmla="val 6667"/>
+              <a:gd name="adj" fmla="val 50000"/>
             </a:avLst>
           </a:prstGeom>
           <a:solidFill>
-            <a:srgbClr val="FFF4BF"/>
+            <a:srgbClr val="FFFFFF"/>
           </a:solidFill>
           <a:ln w="12700">
             <a:solidFill>
-              <a:srgbClr val="D5DCE8"/>
+              <a:srgbClr val="FFFFFF"/>
             </a:solidFill>
             <a:prstDash val="solid"/>
           </a:ln>
         </p:spPr>
       </p:sp>
+      <p:sp>
+        <p:nvSpPr>
+          <p:cNvPr id="14" name="Text 11"/>
+          <p:cNvSpPr txBox="1"/>
+          <p:nvPr/>
+        </p:nvSpPr>
+        <p:spPr>
+          <a:xfrm>
+            <a:off x="777240" y="2834640"/>
+            <a:ext cx="1051560" cy="274320"/>
+          </a:xfrm>
+          <a:prstGeom prst="rect">
+            <a:avLst/>
+          </a:prstGeom>
+          <a:noFill/>
+          <a:ln/>
+        </p:spPr>
+        <p:txBody>
+          <a:bodyPr wrap="square" lIns="0" tIns="0" rIns="0" bIns="0" rtlCol="0" anchor="ctr"/>
+          <a:lstStyle/>
+          <a:p>
+            <a:pPr algn="ctr" indent="0" marL="0">
+              <a:buNone/>
+            </a:pPr>
+            <a:r>
+              <a:rPr lang="en-US" sz="1200" b="1" dirty="0">
+                <a:solidFill>
+                  <a:srgbClr val="001737"/>
+                </a:solidFill>
+                <a:latin typeface="Calibri" pitchFamily="34" charset="0"/>
+                <a:ea typeface="Calibri" pitchFamily="34" charset="-122"/>
+                <a:cs typeface="Calibri" pitchFamily="34" charset="-120"/>
+              </a:rPr>
+              <a:t>8:00 p.m.</a:t>
+            </a:r>
+            <a:endParaRPr lang="en-US" sz="1200" dirty="0"/>
+          </a:p>
+        </p:txBody>
+      </p:sp>
       <p:pic>
         <p:nvPicPr>
-          <p:cNvPr id="16" name="Image 1" descr="Time of day b">    </p:cNvPr>
+          <p:cNvPr id="15" name="Image 1" descr="warmup-b">    </p:cNvPr>
           <p:cNvPicPr>
             <a:picLocks noChangeAspect="1"/>
           </p:cNvPicPr>
@@ -7997,14 +8631,13 @@
         </p:nvPicPr>
         <p:blipFill>
           <a:blip r:embed="rId2"/>
-          <a:stretch>
-            <a:fillRect/>
-          </a:stretch>
+          <a:srcRect l="0" r="0" t="0" b="0"/>
+          <a:stretch/>
         </p:blipFill>
         <p:spPr>
           <a:xfrm>
-            <a:off x="2670048" y="2084832"/>
-            <a:ext cx="548640" cy="548640"/>
+            <a:off x="2194560" y="1828800"/>
+            <a:ext cx="1508760" cy="1371600"/>
           </a:xfrm>
           <a:prstGeom prst="rect">
             <a:avLst/>
@@ -8013,7 +8646,7 @@
       </p:pic>
       <p:sp>
         <p:nvSpPr>
-          <p:cNvPr id="17" name="Pill"/>
+          <p:cNvPr id="16" name="Pill"/>
           <p:cNvSpPr/>
           <p:nvPr/>
         </p:nvSpPr>
@@ -8040,7 +8673,7 @@
       </p:sp>
       <p:sp>
         <p:nvSpPr>
-          <p:cNvPr id="18" name="Text 14"/>
+          <p:cNvPr id="17" name="Text 13"/>
           <p:cNvSpPr txBox="1"/>
           <p:nvPr/>
         </p:nvSpPr>
@@ -8079,73 +8712,73 @@
       </p:sp>
       <p:sp>
         <p:nvSpPr>
-          <p:cNvPr id="19" name="Text 15"/>
-          <p:cNvSpPr txBox="1"/>
-          <p:nvPr/>
-        </p:nvSpPr>
-        <p:spPr>
-          <a:xfrm>
-            <a:off x="2194560" y="2788920"/>
-            <a:ext cx="1508760" cy="320040"/>
-          </a:xfrm>
-          <a:prstGeom prst="rect">
-            <a:avLst/>
-          </a:prstGeom>
-          <a:noFill/>
-          <a:ln/>
-        </p:spPr>
-        <p:txBody>
-          <a:bodyPr wrap="square" lIns="0" tIns="0" rIns="0" bIns="0" rtlCol="0" anchor="ctr"/>
-          <a:lstStyle/>
-          <a:p>
-            <a:pPr algn="ctr" indent="0" marL="0">
-              <a:buNone/>
-            </a:pPr>
-            <a:r>
-              <a:rPr lang="en-US" sz="1300" b="1" dirty="0">
-                <a:solidFill>
-                  <a:srgbClr val="001737"/>
-                </a:solidFill>
-                <a:latin typeface="Calibri" pitchFamily="34" charset="0"/>
-                <a:ea typeface="Calibri" pitchFamily="34" charset="-122"/>
-                <a:cs typeface="Calibri" pitchFamily="34" charset="-120"/>
-              </a:rPr>
-              <a:t>7:00 a.m.</a:t>
-            </a:r>
-            <a:endParaRPr lang="en-US" sz="1300" dirty="0"/>
-          </a:p>
-        </p:txBody>
-      </p:sp>
-      <p:sp>
-        <p:nvSpPr>
-          <p:cNvPr id="20" name="Box"/>
+          <p:cNvPr id="18" name="Pill"/>
           <p:cNvSpPr/>
           <p:nvPr/>
         </p:nvSpPr>
         <p:spPr>
           <a:xfrm>
-            <a:off x="3840480" y="1828800"/>
-            <a:ext cx="1508760" cy="1371600"/>
+            <a:off x="2423160" y="2834640"/>
+            <a:ext cx="1051560" cy="274320"/>
           </a:xfrm>
           <a:prstGeom prst="roundRect">
             <a:avLst>
-              <a:gd name="adj" fmla="val 6667"/>
+              <a:gd name="adj" fmla="val 50000"/>
             </a:avLst>
           </a:prstGeom>
           <a:solidFill>
-            <a:srgbClr val="E2F7EE"/>
+            <a:srgbClr val="FFFFFF"/>
           </a:solidFill>
           <a:ln w="12700">
             <a:solidFill>
-              <a:srgbClr val="D5DCE8"/>
+              <a:srgbClr val="FFFFFF"/>
             </a:solidFill>
             <a:prstDash val="solid"/>
           </a:ln>
         </p:spPr>
       </p:sp>
+      <p:sp>
+        <p:nvSpPr>
+          <p:cNvPr id="19" name="Text 15"/>
+          <p:cNvSpPr txBox="1"/>
+          <p:nvPr/>
+        </p:nvSpPr>
+        <p:spPr>
+          <a:xfrm>
+            <a:off x="2423160" y="2834640"/>
+            <a:ext cx="1051560" cy="274320"/>
+          </a:xfrm>
+          <a:prstGeom prst="rect">
+            <a:avLst/>
+          </a:prstGeom>
+          <a:noFill/>
+          <a:ln/>
+        </p:spPr>
+        <p:txBody>
+          <a:bodyPr wrap="square" lIns="0" tIns="0" rIns="0" bIns="0" rtlCol="0" anchor="ctr"/>
+          <a:lstStyle/>
+          <a:p>
+            <a:pPr algn="ctr" indent="0" marL="0">
+              <a:buNone/>
+            </a:pPr>
+            <a:r>
+              <a:rPr lang="en-US" sz="1200" b="1" dirty="0">
+                <a:solidFill>
+                  <a:srgbClr val="001737"/>
+                </a:solidFill>
+                <a:latin typeface="Calibri" pitchFamily="34" charset="0"/>
+                <a:ea typeface="Calibri" pitchFamily="34" charset="-122"/>
+                <a:cs typeface="Calibri" pitchFamily="34" charset="-120"/>
+              </a:rPr>
+              <a:t>7:00 a.m.</a:t>
+            </a:r>
+            <a:endParaRPr lang="en-US" sz="1200" dirty="0"/>
+          </a:p>
+        </p:txBody>
+      </p:sp>
       <p:pic>
         <p:nvPicPr>
-          <p:cNvPr id="21" name="Image 2" descr="Time of day c">    </p:cNvPr>
+          <p:cNvPr id="20" name="Image 2" descr="warmup-c">    </p:cNvPr>
           <p:cNvPicPr>
             <a:picLocks noChangeAspect="1"/>
           </p:cNvPicPr>
@@ -8153,14 +8786,13 @@
         </p:nvPicPr>
         <p:blipFill>
           <a:blip r:embed="rId3"/>
-          <a:stretch>
-            <a:fillRect/>
-          </a:stretch>
+          <a:srcRect l="0" r="0" t="0" b="0"/>
+          <a:stretch/>
         </p:blipFill>
         <p:spPr>
           <a:xfrm>
-            <a:off x="4315968" y="2084832"/>
-            <a:ext cx="548640" cy="548640"/>
+            <a:off x="3840480" y="1828800"/>
+            <a:ext cx="1508760" cy="1371600"/>
           </a:xfrm>
           <a:prstGeom prst="rect">
             <a:avLst/>
@@ -8169,7 +8801,7 @@
       </p:pic>
       <p:sp>
         <p:nvSpPr>
-          <p:cNvPr id="22" name="Pill"/>
+          <p:cNvPr id="21" name="Pill"/>
           <p:cNvSpPr/>
           <p:nvPr/>
         </p:nvSpPr>
@@ -8196,7 +8828,7 @@
       </p:sp>
       <p:sp>
         <p:nvSpPr>
-          <p:cNvPr id="23" name="Text 18"/>
+          <p:cNvPr id="22" name="Text 17"/>
           <p:cNvSpPr txBox="1"/>
           <p:nvPr/>
         </p:nvSpPr>
@@ -8235,73 +8867,73 @@
       </p:sp>
       <p:sp>
         <p:nvSpPr>
-          <p:cNvPr id="24" name="Text 19"/>
-          <p:cNvSpPr txBox="1"/>
-          <p:nvPr/>
-        </p:nvSpPr>
-        <p:spPr>
-          <a:xfrm>
-            <a:off x="3840480" y="2788920"/>
-            <a:ext cx="1508760" cy="320040"/>
-          </a:xfrm>
-          <a:prstGeom prst="rect">
-            <a:avLst/>
-          </a:prstGeom>
-          <a:noFill/>
-          <a:ln/>
-        </p:spPr>
-        <p:txBody>
-          <a:bodyPr wrap="square" lIns="0" tIns="0" rIns="0" bIns="0" rtlCol="0" anchor="ctr"/>
-          <a:lstStyle/>
-          <a:p>
-            <a:pPr algn="ctr" indent="0" marL="0">
-              <a:buNone/>
-            </a:pPr>
-            <a:r>
-              <a:rPr lang="en-US" sz="1300" b="1" dirty="0">
-                <a:solidFill>
-                  <a:srgbClr val="001737"/>
-                </a:solidFill>
-                <a:latin typeface="Calibri" pitchFamily="34" charset="0"/>
-                <a:ea typeface="Calibri" pitchFamily="34" charset="-122"/>
-                <a:cs typeface="Calibri" pitchFamily="34" charset="-120"/>
-              </a:rPr>
-              <a:t>11:00 p.m.</a:t>
-            </a:r>
-            <a:endParaRPr lang="en-US" sz="1300" dirty="0"/>
-          </a:p>
-        </p:txBody>
-      </p:sp>
-      <p:sp>
-        <p:nvSpPr>
-          <p:cNvPr id="25" name="Box"/>
+          <p:cNvPr id="23" name="Pill"/>
           <p:cNvSpPr/>
           <p:nvPr/>
         </p:nvSpPr>
         <p:spPr>
           <a:xfrm>
-            <a:off x="5486400" y="1828800"/>
-            <a:ext cx="1508760" cy="1371600"/>
+            <a:off x="4069080" y="2834640"/>
+            <a:ext cx="1051560" cy="274320"/>
           </a:xfrm>
           <a:prstGeom prst="roundRect">
             <a:avLst>
-              <a:gd name="adj" fmla="val 6667"/>
+              <a:gd name="adj" fmla="val 50000"/>
             </a:avLst>
           </a:prstGeom>
           <a:solidFill>
-            <a:srgbClr val="E6F3FF"/>
+            <a:srgbClr val="FFFFFF"/>
           </a:solidFill>
           <a:ln w="12700">
             <a:solidFill>
-              <a:srgbClr val="D5DCE8"/>
+              <a:srgbClr val="FFFFFF"/>
             </a:solidFill>
             <a:prstDash val="solid"/>
           </a:ln>
         </p:spPr>
       </p:sp>
+      <p:sp>
+        <p:nvSpPr>
+          <p:cNvPr id="24" name="Text 19"/>
+          <p:cNvSpPr txBox="1"/>
+          <p:nvPr/>
+        </p:nvSpPr>
+        <p:spPr>
+          <a:xfrm>
+            <a:off x="4069080" y="2834640"/>
+            <a:ext cx="1051560" cy="274320"/>
+          </a:xfrm>
+          <a:prstGeom prst="rect">
+            <a:avLst/>
+          </a:prstGeom>
+          <a:noFill/>
+          <a:ln/>
+        </p:spPr>
+        <p:txBody>
+          <a:bodyPr wrap="square" lIns="0" tIns="0" rIns="0" bIns="0" rtlCol="0" anchor="ctr"/>
+          <a:lstStyle/>
+          <a:p>
+            <a:pPr algn="ctr" indent="0" marL="0">
+              <a:buNone/>
+            </a:pPr>
+            <a:r>
+              <a:rPr lang="en-US" sz="1200" b="1" dirty="0">
+                <a:solidFill>
+                  <a:srgbClr val="001737"/>
+                </a:solidFill>
+                <a:latin typeface="Calibri" pitchFamily="34" charset="0"/>
+                <a:ea typeface="Calibri" pitchFamily="34" charset="-122"/>
+                <a:cs typeface="Calibri" pitchFamily="34" charset="-120"/>
+              </a:rPr>
+              <a:t>11:00 p.m.</a:t>
+            </a:r>
+            <a:endParaRPr lang="en-US" sz="1200" dirty="0"/>
+          </a:p>
+        </p:txBody>
+      </p:sp>
       <p:pic>
         <p:nvPicPr>
-          <p:cNvPr id="26" name="Image 3" descr="Time of day d">    </p:cNvPr>
+          <p:cNvPr id="25" name="Image 3" descr="warmup-d">    </p:cNvPr>
           <p:cNvPicPr>
             <a:picLocks noChangeAspect="1"/>
           </p:cNvPicPr>
@@ -8309,14 +8941,13 @@
         </p:nvPicPr>
         <p:blipFill>
           <a:blip r:embed="rId4"/>
-          <a:stretch>
-            <a:fillRect/>
-          </a:stretch>
+          <a:srcRect l="0" r="0" t="0" b="0"/>
+          <a:stretch/>
         </p:blipFill>
         <p:spPr>
           <a:xfrm>
-            <a:off x="5961888" y="2084832"/>
-            <a:ext cx="548640" cy="548640"/>
+            <a:off x="5486400" y="1828800"/>
+            <a:ext cx="1508760" cy="1371600"/>
           </a:xfrm>
           <a:prstGeom prst="rect">
             <a:avLst/>
@@ -8325,7 +8956,7 @@
       </p:pic>
       <p:sp>
         <p:nvSpPr>
-          <p:cNvPr id="27" name="Pill"/>
+          <p:cNvPr id="26" name="Pill"/>
           <p:cNvSpPr/>
           <p:nvPr/>
         </p:nvSpPr>
@@ -8352,7 +8983,7 @@
       </p:sp>
       <p:sp>
         <p:nvSpPr>
-          <p:cNvPr id="28" name="Text 22"/>
+          <p:cNvPr id="27" name="Text 21"/>
           <p:cNvSpPr txBox="1"/>
           <p:nvPr/>
         </p:nvSpPr>
@@ -8391,14 +9022,41 @@
       </p:sp>
       <p:sp>
         <p:nvSpPr>
+          <p:cNvPr id="28" name="Pill"/>
+          <p:cNvSpPr/>
+          <p:nvPr/>
+        </p:nvSpPr>
+        <p:spPr>
+          <a:xfrm>
+            <a:off x="5715000" y="2834640"/>
+            <a:ext cx="1051560" cy="274320"/>
+          </a:xfrm>
+          <a:prstGeom prst="roundRect">
+            <a:avLst>
+              <a:gd name="adj" fmla="val 50000"/>
+            </a:avLst>
+          </a:prstGeom>
+          <a:solidFill>
+            <a:srgbClr val="FFFFFF"/>
+          </a:solidFill>
+          <a:ln w="12700">
+            <a:solidFill>
+              <a:srgbClr val="FFFFFF"/>
+            </a:solidFill>
+            <a:prstDash val="solid"/>
+          </a:ln>
+        </p:spPr>
+      </p:sp>
+      <p:sp>
+        <p:nvSpPr>
           <p:cNvPr id="29" name="Text 23"/>
           <p:cNvSpPr txBox="1"/>
           <p:nvPr/>
         </p:nvSpPr>
         <p:spPr>
           <a:xfrm>
-            <a:off x="5486400" y="2788920"/>
-            <a:ext cx="1508760" cy="320040"/>
+            <a:off x="5715000" y="2834640"/>
+            <a:ext cx="1051560" cy="274320"/>
           </a:xfrm>
           <a:prstGeom prst="rect">
             <a:avLst/>
@@ -8414,7 +9072,7 @@
               <a:buNone/>
             </a:pPr>
             <a:r>
-              <a:rPr lang="en-US" sz="1300" b="1" dirty="0">
+              <a:rPr lang="en-US" sz="1200" b="1" dirty="0">
                 <a:solidFill>
                   <a:srgbClr val="001737"/>
                 </a:solidFill>
@@ -8424,7 +9082,7 @@
               </a:rPr>
               <a:t>3:00 p.m.</a:t>
             </a:r>
-            <a:endParaRPr lang="en-US" sz="1300" dirty="0"/>
+            <a:endParaRPr lang="en-US" sz="1200" dirty="0"/>
           </a:p>
         </p:txBody>
       </p:sp>

</xml_diff>